<commit_message>
Add the meeting minutes and the final slides
</commit_message>
<xml_diff>
--- a/Plagiarism_Detector_Presentation.pptx
+++ b/Plagiarism_Detector_Presentation.pptx
@@ -5,16 +5,12 @@
     <p:sldMasterId id="2147483648" r:id="rId1"/>
   </p:sldMasterIdLst>
   <p:sldIdLst>
-    <p:sldId id="256" r:id="rId7"/>
-    <p:sldId id="257" r:id="rId8"/>
-    <p:sldId id="258" r:id="rId9"/>
-    <p:sldId id="259" r:id="rId10"/>
-    <p:sldId id="260" r:id="rId11"/>
-    <p:sldId id="261" r:id="rId12"/>
-    <p:sldId id="262" r:id="rId13"/>
-    <p:sldId id="263" r:id="rId14"/>
-    <p:sldId id="264" r:id="rId15"/>
-    <p:sldId id="265" r:id="rId16"/>
+    <p:sldId id="256" r:id="rId2"/>
+    <p:sldId id="257" r:id="rId3"/>
+    <p:sldId id="258" r:id="rId4"/>
+    <p:sldId id="259" r:id="rId5"/>
+    <p:sldId id="260" r:id="rId6"/>
+    <p:sldId id="261" r:id="rId7"/>
   </p:sldIdLst>
   <p:sldSz cx="9144000" cy="6858000" type="screen4x3"/>
   <p:notesSz cx="6858000" cy="9144000"/>
@@ -113,6 +109,22 @@
       </a:defRPr>
     </a:lvl9pPr>
   </p:defaultTextStyle>
+  <p:extLst>
+    <p:ext uri="{EFAFB233-063F-42B5-8137-9DF3F51BA10A}">
+      <p15:sldGuideLst xmlns:p15="http://schemas.microsoft.com/office/powerpoint/2012/main">
+        <p15:guide id="1" orient="horz" pos="2160">
+          <p15:clr>
+            <a:srgbClr val="A4A3A4"/>
+          </p15:clr>
+        </p15:guide>
+        <p15:guide id="2" pos="2880">
+          <p15:clr>
+            <a:srgbClr val="A4A3A4"/>
+          </p15:clr>
+        </p15:guide>
+      </p15:sldGuideLst>
+    </p:ext>
+  </p:extLst>
 </p:presentation>
 </file>
 
@@ -154,10 +166,9 @@
           <a:lstStyle/>
           <a:p>
             <a:r>
-              <a:rPr lang="en-US" smtClean="0"/>
+              <a:rPr lang="en-US"/>
               <a:t>Click to edit Master title style</a:t>
             </a:r>
-            <a:endParaRPr lang="en-US"/>
           </a:p>
         </p:txBody>
       </p:sp>
@@ -273,10 +284,9 @@
           </a:lstStyle>
           <a:p>
             <a:r>
-              <a:rPr lang="en-US" smtClean="0"/>
+              <a:rPr lang="en-US"/>
               <a:t>Click to edit Master subtitle style</a:t>
             </a:r>
-            <a:endParaRPr lang="en-US"/>
           </a:p>
         </p:txBody>
       </p:sp>
@@ -297,7 +307,7 @@
           <a:p>
             <a:fld id="{5BCAD085-E8A6-8845-BD4E-CB4CCA059FC4}" type="datetimeFigureOut">
               <a:rPr lang="en-US" smtClean="0"/>
-              <a:t>1/27/13</a:t>
+              <a:t>7/28/2026</a:t>
             </a:fld>
             <a:endParaRPr lang="en-US"/>
           </a:p>
@@ -391,10 +401,9 @@
           <a:lstStyle/>
           <a:p>
             <a:r>
-              <a:rPr lang="en-US" smtClean="0"/>
+              <a:rPr lang="en-US"/>
               <a:t>Click to edit Master title style</a:t>
             </a:r>
-            <a:endParaRPr lang="en-US"/>
           </a:p>
         </p:txBody>
       </p:sp>
@@ -415,38 +424,37 @@
           <a:p>
             <a:pPr lvl="0"/>
             <a:r>
-              <a:rPr lang="en-US" smtClean="0"/>
+              <a:rPr lang="en-US"/>
               <a:t>Click to edit Master text styles</a:t>
             </a:r>
           </a:p>
           <a:p>
             <a:pPr lvl="1"/>
             <a:r>
-              <a:rPr lang="en-US" smtClean="0"/>
+              <a:rPr lang="en-US"/>
               <a:t>Second level</a:t>
             </a:r>
           </a:p>
           <a:p>
             <a:pPr lvl="2"/>
             <a:r>
-              <a:rPr lang="en-US" smtClean="0"/>
+              <a:rPr lang="en-US"/>
               <a:t>Third level</a:t>
             </a:r>
           </a:p>
           <a:p>
             <a:pPr lvl="3"/>
             <a:r>
-              <a:rPr lang="en-US" smtClean="0"/>
+              <a:rPr lang="en-US"/>
               <a:t>Fourth level</a:t>
             </a:r>
           </a:p>
           <a:p>
             <a:pPr lvl="4"/>
             <a:r>
-              <a:rPr lang="en-US" smtClean="0"/>
+              <a:rPr lang="en-US"/>
               <a:t>Fifth level</a:t>
             </a:r>
-            <a:endParaRPr lang="en-US"/>
           </a:p>
         </p:txBody>
       </p:sp>
@@ -467,7 +475,7 @@
           <a:p>
             <a:fld id="{5BCAD085-E8A6-8845-BD4E-CB4CCA059FC4}" type="datetimeFigureOut">
               <a:rPr lang="en-US" smtClean="0"/>
-              <a:t>1/27/13</a:t>
+              <a:t>7/28/2026</a:t>
             </a:fld>
             <a:endParaRPr lang="en-US"/>
           </a:p>
@@ -566,10 +574,9 @@
           <a:lstStyle/>
           <a:p>
             <a:r>
-              <a:rPr lang="en-US" smtClean="0"/>
+              <a:rPr lang="en-US"/>
               <a:t>Click to edit Master title style</a:t>
             </a:r>
-            <a:endParaRPr lang="en-US"/>
           </a:p>
         </p:txBody>
       </p:sp>
@@ -595,38 +602,37 @@
           <a:p>
             <a:pPr lvl="0"/>
             <a:r>
-              <a:rPr lang="en-US" smtClean="0"/>
+              <a:rPr lang="en-US"/>
               <a:t>Click to edit Master text styles</a:t>
             </a:r>
           </a:p>
           <a:p>
             <a:pPr lvl="1"/>
             <a:r>
-              <a:rPr lang="en-US" smtClean="0"/>
+              <a:rPr lang="en-US"/>
               <a:t>Second level</a:t>
             </a:r>
           </a:p>
           <a:p>
             <a:pPr lvl="2"/>
             <a:r>
-              <a:rPr lang="en-US" smtClean="0"/>
+              <a:rPr lang="en-US"/>
               <a:t>Third level</a:t>
             </a:r>
           </a:p>
           <a:p>
             <a:pPr lvl="3"/>
             <a:r>
-              <a:rPr lang="en-US" smtClean="0"/>
+              <a:rPr lang="en-US"/>
               <a:t>Fourth level</a:t>
             </a:r>
           </a:p>
           <a:p>
             <a:pPr lvl="4"/>
             <a:r>
-              <a:rPr lang="en-US" smtClean="0"/>
+              <a:rPr lang="en-US"/>
               <a:t>Fifth level</a:t>
             </a:r>
-            <a:endParaRPr lang="en-US"/>
           </a:p>
         </p:txBody>
       </p:sp>
@@ -647,7 +653,7 @@
           <a:p>
             <a:fld id="{5BCAD085-E8A6-8845-BD4E-CB4CCA059FC4}" type="datetimeFigureOut">
               <a:rPr lang="en-US" smtClean="0"/>
-              <a:t>1/27/13</a:t>
+              <a:t>7/28/2026</a:t>
             </a:fld>
             <a:endParaRPr lang="en-US"/>
           </a:p>
@@ -741,10 +747,9 @@
           <a:lstStyle/>
           <a:p>
             <a:r>
-              <a:rPr lang="en-US" smtClean="0"/>
+              <a:rPr lang="en-US"/>
               <a:t>Click to edit Master title style</a:t>
             </a:r>
-            <a:endParaRPr lang="en-US"/>
           </a:p>
         </p:txBody>
       </p:sp>
@@ -765,38 +770,37 @@
           <a:p>
             <a:pPr lvl="0"/>
             <a:r>
-              <a:rPr lang="en-US" smtClean="0"/>
+              <a:rPr lang="en-US"/>
               <a:t>Click to edit Master text styles</a:t>
             </a:r>
           </a:p>
           <a:p>
             <a:pPr lvl="1"/>
             <a:r>
-              <a:rPr lang="en-US" smtClean="0"/>
+              <a:rPr lang="en-US"/>
               <a:t>Second level</a:t>
             </a:r>
           </a:p>
           <a:p>
             <a:pPr lvl="2"/>
             <a:r>
-              <a:rPr lang="en-US" smtClean="0"/>
+              <a:rPr lang="en-US"/>
               <a:t>Third level</a:t>
             </a:r>
           </a:p>
           <a:p>
             <a:pPr lvl="3"/>
             <a:r>
-              <a:rPr lang="en-US" smtClean="0"/>
+              <a:rPr lang="en-US"/>
               <a:t>Fourth level</a:t>
             </a:r>
           </a:p>
           <a:p>
             <a:pPr lvl="4"/>
             <a:r>
-              <a:rPr lang="en-US" smtClean="0"/>
+              <a:rPr lang="en-US"/>
               <a:t>Fifth level</a:t>
             </a:r>
-            <a:endParaRPr lang="en-US"/>
           </a:p>
         </p:txBody>
       </p:sp>
@@ -817,7 +821,7 @@
           <a:p>
             <a:fld id="{5BCAD085-E8A6-8845-BD4E-CB4CCA059FC4}" type="datetimeFigureOut">
               <a:rPr lang="en-US" smtClean="0"/>
-              <a:t>1/27/13</a:t>
+              <a:t>7/28/2026</a:t>
             </a:fld>
             <a:endParaRPr lang="en-US"/>
           </a:p>
@@ -920,10 +924,9 @@
           </a:lstStyle>
           <a:p>
             <a:r>
-              <a:rPr lang="en-US" smtClean="0"/>
+              <a:rPr lang="en-US"/>
               <a:t>Click to edit Master title style</a:t>
             </a:r>
-            <a:endParaRPr lang="en-US"/>
           </a:p>
         </p:txBody>
       </p:sp>
@@ -1040,7 +1043,7 @@
           <a:p>
             <a:pPr lvl="0"/>
             <a:r>
-              <a:rPr lang="en-US" smtClean="0"/>
+              <a:rPr lang="en-US"/>
               <a:t>Click to edit Master text styles</a:t>
             </a:r>
           </a:p>
@@ -1063,7 +1066,7 @@
           <a:p>
             <a:fld id="{5BCAD085-E8A6-8845-BD4E-CB4CCA059FC4}" type="datetimeFigureOut">
               <a:rPr lang="en-US" smtClean="0"/>
-              <a:t>1/27/13</a:t>
+              <a:t>7/28/2026</a:t>
             </a:fld>
             <a:endParaRPr lang="en-US"/>
           </a:p>
@@ -1157,10 +1160,9 @@
           <a:lstStyle/>
           <a:p>
             <a:r>
-              <a:rPr lang="en-US" smtClean="0"/>
+              <a:rPr lang="en-US"/>
               <a:t>Click to edit Master title style</a:t>
             </a:r>
-            <a:endParaRPr lang="en-US"/>
           </a:p>
         </p:txBody>
       </p:sp>
@@ -1214,38 +1216,37 @@
           <a:p>
             <a:pPr lvl="0"/>
             <a:r>
-              <a:rPr lang="en-US" smtClean="0"/>
+              <a:rPr lang="en-US"/>
               <a:t>Click to edit Master text styles</a:t>
             </a:r>
           </a:p>
           <a:p>
             <a:pPr lvl="1"/>
             <a:r>
-              <a:rPr lang="en-US" smtClean="0"/>
+              <a:rPr lang="en-US"/>
               <a:t>Second level</a:t>
             </a:r>
           </a:p>
           <a:p>
             <a:pPr lvl="2"/>
             <a:r>
-              <a:rPr lang="en-US" smtClean="0"/>
+              <a:rPr lang="en-US"/>
               <a:t>Third level</a:t>
             </a:r>
           </a:p>
           <a:p>
             <a:pPr lvl="3"/>
             <a:r>
-              <a:rPr lang="en-US" smtClean="0"/>
+              <a:rPr lang="en-US"/>
               <a:t>Fourth level</a:t>
             </a:r>
           </a:p>
           <a:p>
             <a:pPr lvl="4"/>
             <a:r>
-              <a:rPr lang="en-US" smtClean="0"/>
+              <a:rPr lang="en-US"/>
               <a:t>Fifth level</a:t>
             </a:r>
-            <a:endParaRPr lang="en-US"/>
           </a:p>
         </p:txBody>
       </p:sp>
@@ -1299,38 +1300,37 @@
           <a:p>
             <a:pPr lvl="0"/>
             <a:r>
-              <a:rPr lang="en-US" smtClean="0"/>
+              <a:rPr lang="en-US"/>
               <a:t>Click to edit Master text styles</a:t>
             </a:r>
           </a:p>
           <a:p>
             <a:pPr lvl="1"/>
             <a:r>
-              <a:rPr lang="en-US" smtClean="0"/>
+              <a:rPr lang="en-US"/>
               <a:t>Second level</a:t>
             </a:r>
           </a:p>
           <a:p>
             <a:pPr lvl="2"/>
             <a:r>
-              <a:rPr lang="en-US" smtClean="0"/>
+              <a:rPr lang="en-US"/>
               <a:t>Third level</a:t>
             </a:r>
           </a:p>
           <a:p>
             <a:pPr lvl="3"/>
             <a:r>
-              <a:rPr lang="en-US" smtClean="0"/>
+              <a:rPr lang="en-US"/>
               <a:t>Fourth level</a:t>
             </a:r>
           </a:p>
           <a:p>
             <a:pPr lvl="4"/>
             <a:r>
-              <a:rPr lang="en-US" smtClean="0"/>
+              <a:rPr lang="en-US"/>
               <a:t>Fifth level</a:t>
             </a:r>
-            <a:endParaRPr lang="en-US"/>
           </a:p>
         </p:txBody>
       </p:sp>
@@ -1351,7 +1351,7 @@
           <a:p>
             <a:fld id="{5BCAD085-E8A6-8845-BD4E-CB4CCA059FC4}" type="datetimeFigureOut">
               <a:rPr lang="en-US" smtClean="0"/>
-              <a:t>1/27/13</a:t>
+              <a:t>7/28/2026</a:t>
             </a:fld>
             <a:endParaRPr lang="en-US"/>
           </a:p>
@@ -1449,10 +1449,9 @@
           </a:lstStyle>
           <a:p>
             <a:r>
-              <a:rPr lang="en-US" smtClean="0"/>
+              <a:rPr lang="en-US"/>
               <a:t>Click to edit Master title style</a:t>
             </a:r>
-            <a:endParaRPr lang="en-US"/>
           </a:p>
         </p:txBody>
       </p:sp>
@@ -1515,7 +1514,7 @@
           <a:p>
             <a:pPr lvl="0"/>
             <a:r>
-              <a:rPr lang="en-US" smtClean="0"/>
+              <a:rPr lang="en-US"/>
               <a:t>Click to edit Master text styles</a:t>
             </a:r>
           </a:p>
@@ -1571,38 +1570,37 @@
           <a:p>
             <a:pPr lvl="0"/>
             <a:r>
-              <a:rPr lang="en-US" smtClean="0"/>
+              <a:rPr lang="en-US"/>
               <a:t>Click to edit Master text styles</a:t>
             </a:r>
           </a:p>
           <a:p>
             <a:pPr lvl="1"/>
             <a:r>
-              <a:rPr lang="en-US" smtClean="0"/>
+              <a:rPr lang="en-US"/>
               <a:t>Second level</a:t>
             </a:r>
           </a:p>
           <a:p>
             <a:pPr lvl="2"/>
             <a:r>
-              <a:rPr lang="en-US" smtClean="0"/>
+              <a:rPr lang="en-US"/>
               <a:t>Third level</a:t>
             </a:r>
           </a:p>
           <a:p>
             <a:pPr lvl="3"/>
             <a:r>
-              <a:rPr lang="en-US" smtClean="0"/>
+              <a:rPr lang="en-US"/>
               <a:t>Fourth level</a:t>
             </a:r>
           </a:p>
           <a:p>
             <a:pPr lvl="4"/>
             <a:r>
-              <a:rPr lang="en-US" smtClean="0"/>
+              <a:rPr lang="en-US"/>
               <a:t>Fifth level</a:t>
             </a:r>
-            <a:endParaRPr lang="en-US"/>
           </a:p>
         </p:txBody>
       </p:sp>
@@ -1665,7 +1663,7 @@
           <a:p>
             <a:pPr lvl="0"/>
             <a:r>
-              <a:rPr lang="en-US" smtClean="0"/>
+              <a:rPr lang="en-US"/>
               <a:t>Click to edit Master text styles</a:t>
             </a:r>
           </a:p>
@@ -1721,38 +1719,37 @@
           <a:p>
             <a:pPr lvl="0"/>
             <a:r>
-              <a:rPr lang="en-US" smtClean="0"/>
+              <a:rPr lang="en-US"/>
               <a:t>Click to edit Master text styles</a:t>
             </a:r>
           </a:p>
           <a:p>
             <a:pPr lvl="1"/>
             <a:r>
-              <a:rPr lang="en-US" smtClean="0"/>
+              <a:rPr lang="en-US"/>
               <a:t>Second level</a:t>
             </a:r>
           </a:p>
           <a:p>
             <a:pPr lvl="2"/>
             <a:r>
-              <a:rPr lang="en-US" smtClean="0"/>
+              <a:rPr lang="en-US"/>
               <a:t>Third level</a:t>
             </a:r>
           </a:p>
           <a:p>
             <a:pPr lvl="3"/>
             <a:r>
-              <a:rPr lang="en-US" smtClean="0"/>
+              <a:rPr lang="en-US"/>
               <a:t>Fourth level</a:t>
             </a:r>
           </a:p>
           <a:p>
             <a:pPr lvl="4"/>
             <a:r>
-              <a:rPr lang="en-US" smtClean="0"/>
+              <a:rPr lang="en-US"/>
               <a:t>Fifth level</a:t>
             </a:r>
-            <a:endParaRPr lang="en-US"/>
           </a:p>
         </p:txBody>
       </p:sp>
@@ -1773,7 +1770,7 @@
           <a:p>
             <a:fld id="{5BCAD085-E8A6-8845-BD4E-CB4CCA059FC4}" type="datetimeFigureOut">
               <a:rPr lang="en-US" smtClean="0"/>
-              <a:t>1/27/13</a:t>
+              <a:t>7/28/2026</a:t>
             </a:fld>
             <a:endParaRPr lang="en-US"/>
           </a:p>
@@ -1867,10 +1864,9 @@
           <a:lstStyle/>
           <a:p>
             <a:r>
-              <a:rPr lang="en-US" smtClean="0"/>
+              <a:rPr lang="en-US"/>
               <a:t>Click to edit Master title style</a:t>
             </a:r>
-            <a:endParaRPr lang="en-US"/>
           </a:p>
         </p:txBody>
       </p:sp>
@@ -1891,7 +1887,7 @@
           <a:p>
             <a:fld id="{5BCAD085-E8A6-8845-BD4E-CB4CCA059FC4}" type="datetimeFigureOut">
               <a:rPr lang="en-US" smtClean="0"/>
-              <a:t>1/27/13</a:t>
+              <a:t>7/28/2026</a:t>
             </a:fld>
             <a:endParaRPr lang="en-US"/>
           </a:p>
@@ -1986,7 +1982,7 @@
           <a:p>
             <a:fld id="{5BCAD085-E8A6-8845-BD4E-CB4CCA059FC4}" type="datetimeFigureOut">
               <a:rPr lang="en-US" smtClean="0"/>
-              <a:t>1/27/13</a:t>
+              <a:t>7/28/2026</a:t>
             </a:fld>
             <a:endParaRPr lang="en-US"/>
           </a:p>
@@ -2089,10 +2085,9 @@
           </a:lstStyle>
           <a:p>
             <a:r>
-              <a:rPr lang="en-US" smtClean="0"/>
+              <a:rPr lang="en-US"/>
               <a:t>Click to edit Master title style</a:t>
             </a:r>
-            <a:endParaRPr lang="en-US"/>
           </a:p>
         </p:txBody>
       </p:sp>
@@ -2146,38 +2141,37 @@
           <a:p>
             <a:pPr lvl="0"/>
             <a:r>
-              <a:rPr lang="en-US" smtClean="0"/>
+              <a:rPr lang="en-US"/>
               <a:t>Click to edit Master text styles</a:t>
             </a:r>
           </a:p>
           <a:p>
             <a:pPr lvl="1"/>
             <a:r>
-              <a:rPr lang="en-US" smtClean="0"/>
+              <a:rPr lang="en-US"/>
               <a:t>Second level</a:t>
             </a:r>
           </a:p>
           <a:p>
             <a:pPr lvl="2"/>
             <a:r>
-              <a:rPr lang="en-US" smtClean="0"/>
+              <a:rPr lang="en-US"/>
               <a:t>Third level</a:t>
             </a:r>
           </a:p>
           <a:p>
             <a:pPr lvl="3"/>
             <a:r>
-              <a:rPr lang="en-US" smtClean="0"/>
+              <a:rPr lang="en-US"/>
               <a:t>Fourth level</a:t>
             </a:r>
           </a:p>
           <a:p>
             <a:pPr lvl="4"/>
             <a:r>
-              <a:rPr lang="en-US" smtClean="0"/>
+              <a:rPr lang="en-US"/>
               <a:t>Fifth level</a:t>
             </a:r>
-            <a:endParaRPr lang="en-US"/>
           </a:p>
         </p:txBody>
       </p:sp>
@@ -2240,7 +2234,7 @@
           <a:p>
             <a:pPr lvl="0"/>
             <a:r>
-              <a:rPr lang="en-US" smtClean="0"/>
+              <a:rPr lang="en-US"/>
               <a:t>Click to edit Master text styles</a:t>
             </a:r>
           </a:p>
@@ -2263,7 +2257,7 @@
           <a:p>
             <a:fld id="{5BCAD085-E8A6-8845-BD4E-CB4CCA059FC4}" type="datetimeFigureOut">
               <a:rPr lang="en-US" smtClean="0"/>
-              <a:t>1/27/13</a:t>
+              <a:t>7/28/2026</a:t>
             </a:fld>
             <a:endParaRPr lang="en-US"/>
           </a:p>
@@ -2366,10 +2360,9 @@
           </a:lstStyle>
           <a:p>
             <a:r>
-              <a:rPr lang="en-US" smtClean="0"/>
+              <a:rPr lang="en-US"/>
               <a:t>Click to edit Master title style</a:t>
             </a:r>
-            <a:endParaRPr lang="en-US"/>
           </a:p>
         </p:txBody>
       </p:sp>
@@ -2493,7 +2486,7 @@
           <a:p>
             <a:pPr lvl="0"/>
             <a:r>
-              <a:rPr lang="en-US" smtClean="0"/>
+              <a:rPr lang="en-US"/>
               <a:t>Click to edit Master text styles</a:t>
             </a:r>
           </a:p>
@@ -2516,7 +2509,7 @@
           <a:p>
             <a:fld id="{5BCAD085-E8A6-8845-BD4E-CB4CCA059FC4}" type="datetimeFigureOut">
               <a:rPr lang="en-US" smtClean="0"/>
-              <a:t>1/27/13</a:t>
+              <a:t>7/28/2026</a:t>
             </a:fld>
             <a:endParaRPr lang="en-US"/>
           </a:p>
@@ -2625,10 +2618,9 @@
           <a:lstStyle/>
           <a:p>
             <a:r>
-              <a:rPr lang="en-US" smtClean="0"/>
+              <a:rPr lang="en-US"/>
               <a:t>Click to edit Master title style</a:t>
             </a:r>
-            <a:endParaRPr lang="en-US"/>
           </a:p>
         </p:txBody>
       </p:sp>
@@ -2659,38 +2651,37 @@
           <a:p>
             <a:pPr lvl="0"/>
             <a:r>
-              <a:rPr lang="en-US" smtClean="0"/>
+              <a:rPr lang="en-US"/>
               <a:t>Click to edit Master text styles</a:t>
             </a:r>
           </a:p>
           <a:p>
             <a:pPr lvl="1"/>
             <a:r>
-              <a:rPr lang="en-US" smtClean="0"/>
+              <a:rPr lang="en-US"/>
               <a:t>Second level</a:t>
             </a:r>
           </a:p>
           <a:p>
             <a:pPr lvl="2"/>
             <a:r>
-              <a:rPr lang="en-US" smtClean="0"/>
+              <a:rPr lang="en-US"/>
               <a:t>Third level</a:t>
             </a:r>
           </a:p>
           <a:p>
             <a:pPr lvl="3"/>
             <a:r>
-              <a:rPr lang="en-US" smtClean="0"/>
+              <a:rPr lang="en-US"/>
               <a:t>Fourth level</a:t>
             </a:r>
           </a:p>
           <a:p>
             <a:pPr lvl="4"/>
             <a:r>
-              <a:rPr lang="en-US" smtClean="0"/>
+              <a:rPr lang="en-US"/>
               <a:t>Fifth level</a:t>
             </a:r>
-            <a:endParaRPr lang="en-US"/>
           </a:p>
         </p:txBody>
       </p:sp>
@@ -2729,7 +2720,7 @@
           <a:p>
             <a:fld id="{5BCAD085-E8A6-8845-BD4E-CB4CCA059FC4}" type="datetimeFigureOut">
               <a:rPr lang="en-US" smtClean="0"/>
-              <a:t>1/27/13</a:t>
+              <a:t>7/28/2026</a:t>
             </a:fld>
             <a:endParaRPr lang="en-US"/>
           </a:p>
@@ -3088,7 +3079,7 @@
 </file>
 
 <file path=ppt/slides/slide1.xml><?xml version="1.0" encoding="utf-8"?>
-<p:sld xmlns:a="http://schemas.openxmlformats.org/drawingml/2006/main" xmlns:p="http://schemas.openxmlformats.org/presentationml/2006/main" xmlns:r="http://schemas.openxmlformats.org/officeDocument/2006/relationships">
+<p:sld xmlns:a="http://schemas.openxmlformats.org/drawingml/2006/main" xmlns:r="http://schemas.openxmlformats.org/officeDocument/2006/relationships" xmlns:p="http://schemas.openxmlformats.org/presentationml/2006/main">
   <p:cSld>
     <p:spTree>
       <p:nvGrpSpPr>
@@ -3096,7 +3087,14 @@
         <p:cNvGrpSpPr/>
         <p:nvPr/>
       </p:nvGrpSpPr>
-      <p:grpSpPr/>
+      <p:grpSpPr>
+        <a:xfrm>
+          <a:off x="0" y="0"/>
+          <a:ext cx="0" cy="0"/>
+          <a:chOff x="0" y="0"/>
+          <a:chExt cx="0" cy="0"/>
+        </a:xfrm>
+      </p:grpSpPr>
       <p:sp>
         <p:nvSpPr>
           <p:cNvPr id="2" name="Title 1"/>
@@ -3107,12 +3105,18 @@
             <p:ph type="ctrTitle"/>
           </p:nvPr>
         </p:nvSpPr>
-        <p:spPr/>
-        <p:txBody>
-          <a:bodyPr/>
-          <a:lstStyle/>
-          <a:p>
-            <a:r>
+        <p:spPr>
+          <a:xfrm>
+            <a:off x="685800" y="190306"/>
+            <a:ext cx="7772400" cy="1470025"/>
+          </a:xfrm>
+        </p:spPr>
+        <p:txBody>
+          <a:bodyPr/>
+          <a:lstStyle/>
+          <a:p>
+            <a:r>
+              <a:rPr dirty="0"/>
               <a:t>Plagiarism Detector</a:t>
             </a:r>
           </a:p>
@@ -3128,111 +3132,130 @@
             <p:ph type="subTitle" idx="1"/>
           </p:nvPr>
         </p:nvSpPr>
-        <p:spPr/>
-        <p:txBody>
-          <a:bodyPr/>
-          <a:lstStyle/>
-          <a:p>
-            <a:r>
+        <p:spPr>
+          <a:xfrm>
+            <a:off x="1474967" y="1198658"/>
+            <a:ext cx="6400800" cy="5469035"/>
+          </a:xfrm>
+        </p:spPr>
+        <p:txBody>
+          <a:bodyPr>
+            <a:normAutofit fontScale="92500" lnSpcReduction="10000"/>
+          </a:bodyPr>
+          <a:lstStyle/>
+          <a:p>
+            <a:r>
+              <a:rPr dirty="0">
+                <a:solidFill>
+                  <a:schemeClr val="tx1"/>
+                </a:solidFill>
+              </a:rPr>
               <a:t>Minor II Project Progress Presentation</a:t>
             </a:r>
           </a:p>
-          <a:p/>
-          <a:p>
-            <a:r>
-              <a:t>Presented to: Santosh Panth, Assistant Professor</a:t>
-            </a:r>
-          </a:p>
-          <a:p>
-            <a:r>
+          <a:p>
+            <a:endParaRPr dirty="0">
+              <a:solidFill>
+                <a:schemeClr val="tx1"/>
+              </a:solidFill>
+            </a:endParaRPr>
+          </a:p>
+          <a:p>
+            <a:r>
+              <a:rPr dirty="0">
+                <a:solidFill>
+                  <a:schemeClr val="tx1"/>
+                </a:solidFill>
+              </a:rPr>
               <a:t>Gandaki College of Engineering and Science</a:t>
             </a:r>
           </a:p>
-          <a:p/>
-          <a:p>
-            <a:r>
+          <a:p>
+            <a:endParaRPr dirty="0">
+              <a:solidFill>
+                <a:schemeClr val="tx1"/>
+              </a:solidFill>
+            </a:endParaRPr>
+          </a:p>
+          <a:p>
+            <a:r>
+              <a:rPr dirty="0">
+                <a:solidFill>
+                  <a:schemeClr val="tx1"/>
+                </a:solidFill>
+              </a:rPr>
               <a:t>Presented by:</a:t>
             </a:r>
           </a:p>
           <a:p>
             <a:r>
+              <a:rPr dirty="0">
+                <a:solidFill>
+                  <a:schemeClr val="tx1"/>
+                </a:solidFill>
+              </a:rPr>
               <a:t>Neon Neupane</a:t>
             </a:r>
           </a:p>
           <a:p>
             <a:r>
+              <a:rPr dirty="0">
+                <a:solidFill>
+                  <a:schemeClr val="tx1"/>
+                </a:solidFill>
+              </a:rPr>
               <a:t>Bishal Acharya</a:t>
             </a:r>
           </a:p>
           <a:p>
             <a:r>
+              <a:rPr dirty="0">
+                <a:solidFill>
+                  <a:schemeClr val="tx1"/>
+                </a:solidFill>
+              </a:rPr>
               <a:t>Nabin Giri</a:t>
             </a:r>
           </a:p>
-          <a:p/>
-          <a:p>
-            <a:r>
-              <a:t>Date: Shrawan 12/14, 2083</a:t>
-            </a:r>
-          </a:p>
-        </p:txBody>
-      </p:sp>
-    </p:spTree>
-  </p:cSld>
-  <p:clrMapOvr>
-    <a:masterClrMapping/>
-  </p:clrMapOvr>
-</p:sld>
-</file>
-
-<file path=ppt/slides/slide10.xml><?xml version="1.0" encoding="utf-8"?>
-<p:sld xmlns:a="http://schemas.openxmlformats.org/drawingml/2006/main" xmlns:p="http://schemas.openxmlformats.org/presentationml/2006/main" xmlns:r="http://schemas.openxmlformats.org/officeDocument/2006/relationships">
-  <p:cSld>
-    <p:spTree>
-      <p:nvGrpSpPr>
-        <p:cNvPr id="1" name=""/>
-        <p:cNvGrpSpPr/>
-        <p:nvPr/>
-      </p:nvGrpSpPr>
-      <p:grpSpPr/>
-      <p:sp>
-        <p:nvSpPr>
-          <p:cNvPr id="2" name="Title 1"/>
-          <p:cNvSpPr>
-            <a:spLocks noGrp="1"/>
-          </p:cNvSpPr>
-          <p:nvPr>
-            <p:ph type="ctrTitle"/>
-          </p:nvPr>
-        </p:nvSpPr>
-        <p:spPr/>
-        <p:txBody>
-          <a:bodyPr/>
-          <a:lstStyle/>
-          <a:p>
-            <a:r>
-              <a:t>Thank You!</a:t>
-            </a:r>
-          </a:p>
-        </p:txBody>
-      </p:sp>
-      <p:sp>
-        <p:nvSpPr>
-          <p:cNvPr id="3" name="Subtitle 2"/>
-          <p:cNvSpPr>
-            <a:spLocks noGrp="1"/>
-          </p:cNvSpPr>
-          <p:nvPr>
-            <p:ph type="subTitle" idx="1"/>
-          </p:nvPr>
-        </p:nvSpPr>
-        <p:spPr/>
-        <p:txBody>
-          <a:bodyPr/>
-          <a:lstStyle/>
-          <a:p>
-            <a:r>
-              <a:t>Questions &amp; Feedback?</a:t>
+          <a:p>
+            <a:endParaRPr dirty="0">
+              <a:solidFill>
+                <a:schemeClr val="tx1"/>
+              </a:solidFill>
+            </a:endParaRPr>
+          </a:p>
+          <a:p>
+            <a:r>
+              <a:rPr dirty="0">
+                <a:solidFill>
+                  <a:schemeClr val="tx1"/>
+                </a:solidFill>
+              </a:rPr>
+              <a:t>Date: </a:t>
+            </a:r>
+            <a:r>
+              <a:rPr dirty="0" err="1">
+                <a:solidFill>
+                  <a:schemeClr val="tx1"/>
+                </a:solidFill>
+              </a:rPr>
+              <a:t>Shrawan</a:t>
+            </a:r>
+            <a:r>
+              <a:rPr>
+                <a:solidFill>
+                  <a:schemeClr val="tx1"/>
+                </a:solidFill>
+              </a:rPr>
+              <a:t> 12, </a:t>
+            </a:r>
+            <a:r>
+              <a:rPr dirty="0">
+                <a:solidFill>
+                  <a:schemeClr val="tx1"/>
+                </a:solidFill>
+              </a:rPr>
+              <a:t>2083</a:t>
             </a:r>
           </a:p>
         </p:txBody>
@@ -3246,7 +3269,7 @@
 </file>
 
 <file path=ppt/slides/slide2.xml><?xml version="1.0" encoding="utf-8"?>
-<p:sld xmlns:a="http://schemas.openxmlformats.org/drawingml/2006/main" xmlns:p="http://schemas.openxmlformats.org/presentationml/2006/main" xmlns:r="http://schemas.openxmlformats.org/officeDocument/2006/relationships">
+<p:sld xmlns:a="http://schemas.openxmlformats.org/drawingml/2006/main" xmlns:r="http://schemas.openxmlformats.org/officeDocument/2006/relationships" xmlns:p="http://schemas.openxmlformats.org/presentationml/2006/main">
   <p:cSld>
     <p:spTree>
       <p:nvGrpSpPr>
@@ -3254,7 +3277,14 @@
         <p:cNvGrpSpPr/>
         <p:nvPr/>
       </p:nvGrpSpPr>
-      <p:grpSpPr/>
+      <p:grpSpPr>
+        <a:xfrm>
+          <a:off x="0" y="0"/>
+          <a:ext cx="0" cy="0"/>
+          <a:chOff x="0" y="0"/>
+          <a:chExt cx="0" cy="0"/>
+        </a:xfrm>
+      </p:grpSpPr>
       <p:sp>
         <p:nvSpPr>
           <p:cNvPr id="2" name="Title 1"/>
@@ -3296,7 +3326,6 @@
             </a:r>
           </a:p>
           <a:p>
-            <a:pPr/>
             <a:r>
               <a:t>Key Features:</a:t>
             </a:r>
@@ -3323,12 +3352,6 @@
             <a:pPr lvl="1"/>
             <a:r>
               <a:t>Checks documents against pages on the internet (Web checking).</a:t>
-            </a:r>
-          </a:p>
-          <a:p>
-            <a:pPr/>
-            <a:r>
-              <a:t>Goal: To create a fast, private, and smart system to detect copied work.</a:t>
             </a:r>
           </a:p>
         </p:txBody>
@@ -3342,7 +3365,7 @@
 </file>
 
 <file path=ppt/slides/slide3.xml><?xml version="1.0" encoding="utf-8"?>
-<p:sld xmlns:a="http://schemas.openxmlformats.org/drawingml/2006/main" xmlns:p="http://schemas.openxmlformats.org/presentationml/2006/main" xmlns:r="http://schemas.openxmlformats.org/officeDocument/2006/relationships">
+<p:sld xmlns:a="http://schemas.openxmlformats.org/drawingml/2006/main" xmlns:r="http://schemas.openxmlformats.org/officeDocument/2006/relationships" xmlns:p="http://schemas.openxmlformats.org/presentationml/2006/main">
   <p:cSld>
     <p:spTree>
       <p:nvGrpSpPr>
@@ -3350,7 +3373,14 @@
         <p:cNvGrpSpPr/>
         <p:nvPr/>
       </p:nvGrpSpPr>
-      <p:grpSpPr/>
+      <p:grpSpPr>
+        <a:xfrm>
+          <a:off x="0" y="0"/>
+          <a:ext cx="0" cy="0"/>
+          <a:chOff x="0" y="0"/>
+          <a:chExt cx="0" cy="0"/>
+        </a:xfrm>
+      </p:grpSpPr>
       <p:sp>
         <p:nvSpPr>
           <p:cNvPr id="2" name="Title 1"/>
@@ -3367,7 +3397,7 @@
           <a:lstStyle/>
           <a:p>
             <a:r>
-              <a:t>Project Demonstration</a:t>
+              <a:t>The Brains: Model &amp; Dataset</a:t>
             </a:r>
           </a:p>
         </p:txBody>
@@ -3388,37 +3418,35 @@
           <a:lstStyle/>
           <a:p>
             <a:r>
-              <a:t>(Live Demonstration)</a:t>
-            </a:r>
-          </a:p>
-          <a:p>
-            <a:pPr/>
-            <a:r>
-              <a:t>What we will show:</a:t>
+              <a:t>The Dataset: Trained on the MIT Plagiarism Detection Dataset.</a:t>
+            </a:r>
+          </a:p>
+          <a:p>
+            <a:r>
+              <a:t>The AI Model: Used Sentence-BERT (all-MiniLM-L6-v2).</a:t>
+            </a:r>
+          </a:p>
+          <a:p>
+            <a:r>
+              <a:t>Siamese Network Architecture:</a:t>
             </a:r>
           </a:p>
           <a:p>
             <a:pPr lvl="1"/>
             <a:r>
-              <a:t>Uploading a batch of documents.</a:t>
+              <a:t>It uses twin AI networks that share the same brain (weights).</a:t>
             </a:r>
           </a:p>
           <a:p>
             <a:pPr lvl="1"/>
             <a:r>
-              <a:t>Showing the similarity matrix (who copied from whom).</a:t>
+              <a:t>Both sentences go through the twins to create meaning-numbers (embeddings).</a:t>
             </a:r>
           </a:p>
           <a:p>
             <a:pPr lvl="1"/>
             <a:r>
-              <a:t>Showing the highlighted sentences showing exactly what was copied.</a:t>
-            </a:r>
-          </a:p>
-          <a:p>
-            <a:pPr lvl="1"/>
-            <a:r>
-              <a:t>Demonstrating the web-check feature.</a:t>
+              <a:t>If they mean the same thing, the network pulls them closer together.</a:t>
             </a:r>
           </a:p>
         </p:txBody>
@@ -3432,7 +3460,7 @@
 </file>
 
 <file path=ppt/slides/slide4.xml><?xml version="1.0" encoding="utf-8"?>
-<p:sld xmlns:a="http://schemas.openxmlformats.org/drawingml/2006/main" xmlns:p="http://schemas.openxmlformats.org/presentationml/2006/main" xmlns:r="http://schemas.openxmlformats.org/officeDocument/2006/relationships">
+<p:sld xmlns:a="http://schemas.openxmlformats.org/drawingml/2006/main" xmlns:r="http://schemas.openxmlformats.org/officeDocument/2006/relationships" xmlns:p="http://schemas.openxmlformats.org/presentationml/2006/main">
   <p:cSld>
     <p:spTree>
       <p:nvGrpSpPr>
@@ -3440,7 +3468,14 @@
         <p:cNvGrpSpPr/>
         <p:nvPr/>
       </p:nvGrpSpPr>
-      <p:grpSpPr/>
+      <p:grpSpPr>
+        <a:xfrm>
+          <a:off x="0" y="0"/>
+          <a:ext cx="0" cy="0"/>
+          <a:chOff x="0" y="0"/>
+          <a:chExt cx="0" cy="0"/>
+        </a:xfrm>
+      </p:grpSpPr>
       <p:sp>
         <p:nvSpPr>
           <p:cNvPr id="2" name="Title 1"/>
@@ -3457,7 +3492,7 @@
           <a:lstStyle/>
           <a:p>
             <a:r>
-              <a:t>Work Completed</a:t>
+              <a:t>Web Scraping &amp; Keyword Extraction</a:t>
             </a:r>
           </a:p>
         </p:txBody>
@@ -3478,37 +3513,42 @@
           <a:lstStyle/>
           <a:p>
             <a:r>
-              <a:t>Frontend (User Interface): Built a clean, easy-to-use web page using React.</a:t>
-            </a:r>
-          </a:p>
-          <a:p>
-            <a:pPr/>
-            <a:r>
-              <a:t>Backend (Server): Created a solid backend using Django to process uploads without saving them permanently.</a:t>
-            </a:r>
-          </a:p>
-          <a:p>
-            <a:pPr/>
-            <a:r>
-              <a:t>Core Engine Built:</a:t>
+              <a:rPr dirty="0"/>
+              <a:t>Keyword Extraction:</a:t>
             </a:r>
           </a:p>
           <a:p>
             <a:pPr lvl="1"/>
             <a:r>
-              <a:t>Text extraction from files and images is working.</a:t>
+              <a:rPr dirty="0"/>
+              <a:t>System scans the text and picks the top 6 most frequently used important words (ignoring 'and', 'the').</a:t>
+            </a:r>
+          </a:p>
+          <a:p>
+            <a:r>
+              <a:rPr dirty="0"/>
+              <a:t>Stealthy Scraping:</a:t>
             </a:r>
           </a:p>
           <a:p>
             <a:pPr lvl="1"/>
             <a:r>
-              <a:t>Similarity matching between documents is functional.</a:t>
+              <a:rPr dirty="0"/>
+              <a:t>Searches DuckDuckGo using those keywords to find top 10 URLs.</a:t>
             </a:r>
           </a:p>
           <a:p>
             <a:pPr lvl="1"/>
             <a:r>
-              <a:t>Web checking to find internet plagiarism is active.</a:t>
+              <a:rPr dirty="0"/>
+              <a:t>Visits the URLs and extracts the pure text (ignoring HTML, ads).</a:t>
+            </a:r>
+          </a:p>
+          <a:p>
+            <a:pPr lvl="1"/>
+            <a:r>
+              <a:rPr dirty="0"/>
+              <a:t>Compares the internet text against the uploaded document.</a:t>
             </a:r>
           </a:p>
         </p:txBody>
@@ -3522,7 +3562,7 @@
 </file>
 
 <file path=ppt/slides/slide5.xml><?xml version="1.0" encoding="utf-8"?>
-<p:sld xmlns:a="http://schemas.openxmlformats.org/drawingml/2006/main" xmlns:p="http://schemas.openxmlformats.org/presentationml/2006/main" xmlns:r="http://schemas.openxmlformats.org/officeDocument/2006/relationships">
+<p:sld xmlns:a="http://schemas.openxmlformats.org/drawingml/2006/main" xmlns:r="http://schemas.openxmlformats.org/officeDocument/2006/relationships" xmlns:p="http://schemas.openxmlformats.org/presentationml/2006/main">
   <p:cSld>
     <p:spTree>
       <p:nvGrpSpPr>
@@ -3530,7 +3570,14 @@
         <p:cNvGrpSpPr/>
         <p:nvPr/>
       </p:nvGrpSpPr>
-      <p:grpSpPr/>
+      <p:grpSpPr>
+        <a:xfrm>
+          <a:off x="0" y="0"/>
+          <a:ext cx="0" cy="0"/>
+          <a:chOff x="0" y="0"/>
+          <a:chExt cx="0" cy="0"/>
+        </a:xfrm>
+      </p:grpSpPr>
       <p:sp>
         <p:nvSpPr>
           <p:cNvPr id="2" name="Title 1"/>
@@ -3547,7 +3594,7 @@
           <a:lstStyle/>
           <a:p>
             <a:r>
-              <a:t>The Brains: Model &amp; Dataset</a:t>
+              <a:t>Remaining Work</a:t>
             </a:r>
           </a:p>
         </p:txBody>
@@ -3568,19 +3615,22 @@
           <a:lstStyle/>
           <a:p>
             <a:r>
-              <a:t>The Dataset: Trained on the MIT Plagiarism Detection Dataset (over 366,000 real examples).</a:t>
-            </a:r>
-          </a:p>
-          <a:p>
-            <a:pPr/>
-            <a:r>
-              <a:t>The AI Model: Used Sentence-BERT (all-MiniLM-L6-v2).</a:t>
-            </a:r>
-          </a:p>
-          <a:p>
-            <a:pPr/>
-            <a:r>
-              <a:t>How we trained it: Fine-tuned this model using PyTorch to learn what 'plagiarised' or 'paraphrased' text looks like.</a:t>
+              <a:t>Add support for larger documents by splitting them into smaller chunks.</a:t>
+            </a:r>
+          </a:p>
+          <a:p>
+            <a:r>
+              <a:t>Polish the User Interface to make similarity matrix easier to read on small screens.</a:t>
+            </a:r>
+          </a:p>
+          <a:p>
+            <a:r>
+              <a:t>Add support for checking texts in Devanagari (Nepali).</a:t>
+            </a:r>
+          </a:p>
+          <a:p>
+            <a:r>
+              <a:t>Final testing and bug fixing before final submission.</a:t>
             </a:r>
           </a:p>
         </p:txBody>
@@ -3594,7 +3644,7 @@
 </file>
 
 <file path=ppt/slides/slide6.xml><?xml version="1.0" encoding="utf-8"?>
-<p:sld xmlns:a="http://schemas.openxmlformats.org/drawingml/2006/main" xmlns:p="http://schemas.openxmlformats.org/presentationml/2006/main" xmlns:r="http://schemas.openxmlformats.org/officeDocument/2006/relationships">
+<p:sld xmlns:a="http://schemas.openxmlformats.org/drawingml/2006/main" xmlns:r="http://schemas.openxmlformats.org/officeDocument/2006/relationships" xmlns:p="http://schemas.openxmlformats.org/presentationml/2006/main">
   <p:cSld>
     <p:spTree>
       <p:nvGrpSpPr>
@@ -3602,7 +3652,14 @@
         <p:cNvGrpSpPr/>
         <p:nvPr/>
       </p:nvGrpSpPr>
-      <p:grpSpPr/>
+      <p:grpSpPr>
+        <a:xfrm>
+          <a:off x="0" y="0"/>
+          <a:ext cx="0" cy="0"/>
+          <a:chOff x="0" y="0"/>
+          <a:chExt cx="0" cy="0"/>
+        </a:xfrm>
+      </p:grpSpPr>
       <p:sp>
         <p:nvSpPr>
           <p:cNvPr id="2" name="Title 1"/>
@@ -3610,313 +3667,37 @@
             <a:spLocks noGrp="1"/>
           </p:cNvSpPr>
           <p:nvPr>
-            <p:ph type="title"/>
-          </p:nvPr>
-        </p:nvSpPr>
-        <p:spPr/>
-        <p:txBody>
-          <a:bodyPr/>
-          <a:lstStyle/>
-          <a:p>
-            <a:r>
-              <a:t>How We Calculate Similarity</a:t>
-            </a:r>
-          </a:p>
-        </p:txBody>
-      </p:sp>
-      <p:sp>
-        <p:nvSpPr>
-          <p:cNvPr id="3" name="Content Placeholder 2"/>
-          <p:cNvSpPr>
-            <a:spLocks noGrp="1"/>
-          </p:cNvSpPr>
-          <p:nvPr>
-            <p:ph idx="1"/>
-          </p:nvPr>
-        </p:nvSpPr>
-        <p:spPr/>
-        <p:txBody>
-          <a:bodyPr/>
-          <a:lstStyle/>
-          <a:p>
-            <a:r>
-              <a:t>Simple Word Matching (Baseline): TF-IDF to count important shared words.</a:t>
-            </a:r>
-          </a:p>
-          <a:p>
-            <a:pPr/>
-            <a:r>
-              <a:t>Smart Meaning Matching (AI Model): Trained model turns sentences into embeddings (meaning represented as numbers).</a:t>
-            </a:r>
-          </a:p>
-          <a:p>
-            <a:pPr/>
-            <a:r>
-              <a:t>Cosine Similarity: Compares embeddings to check how close meanings are.</a:t>
-            </a:r>
-          </a:p>
-          <a:p>
-            <a:pPr lvl="1"/>
-            <a:r>
-              <a:t>If the score is above 70%, it gets flagged as copied and highlighted.</a:t>
-            </a:r>
-          </a:p>
-        </p:txBody>
-      </p:sp>
-    </p:spTree>
-  </p:cSld>
-  <p:clrMapOvr>
-    <a:masterClrMapping/>
-  </p:clrMapOvr>
-</p:sld>
-</file>
-
-<file path=ppt/slides/slide7.xml><?xml version="1.0" encoding="utf-8"?>
-<p:sld xmlns:a="http://schemas.openxmlformats.org/drawingml/2006/main" xmlns:p="http://schemas.openxmlformats.org/presentationml/2006/main" xmlns:r="http://schemas.openxmlformats.org/officeDocument/2006/relationships">
-  <p:cSld>
-    <p:spTree>
-      <p:nvGrpSpPr>
-        <p:cNvPr id="1" name=""/>
-        <p:cNvGrpSpPr/>
-        <p:nvPr/>
-      </p:nvGrpSpPr>
-      <p:grpSpPr/>
-      <p:sp>
-        <p:nvSpPr>
-          <p:cNvPr id="2" name="Title 1"/>
-          <p:cNvSpPr>
-            <a:spLocks noGrp="1"/>
-          </p:cNvSpPr>
-          <p:nvPr>
-            <p:ph type="title"/>
-          </p:nvPr>
-        </p:nvSpPr>
-        <p:spPr/>
-        <p:txBody>
-          <a:bodyPr/>
-          <a:lstStyle/>
-          <a:p>
-            <a:r>
-              <a:t>Web Scraping (Checking the Internet)</a:t>
-            </a:r>
-          </a:p>
-        </p:txBody>
-      </p:sp>
-      <p:sp>
-        <p:nvSpPr>
-          <p:cNvPr id="3" name="Content Placeholder 2"/>
-          <p:cNvSpPr>
-            <a:spLocks noGrp="1"/>
-          </p:cNvSpPr>
-          <p:nvPr>
-            <p:ph idx="1"/>
-          </p:nvPr>
-        </p:nvSpPr>
-        <p:spPr/>
-        <p:txBody>
-          <a:bodyPr/>
-          <a:lstStyle/>
-          <a:p>
-            <a:r>
-              <a:t>The Goal: Make sure work wasn't just copy-pasted from websites.</a:t>
-            </a:r>
-          </a:p>
-          <a:p>
-            <a:pPr/>
-            <a:r>
-              <a:t>How it works:</a:t>
-            </a:r>
-          </a:p>
-          <a:p>
-            <a:pPr lvl="1"/>
-            <a:r>
-              <a:t>Extract key phrases from the uploaded document.</a:t>
-            </a:r>
-          </a:p>
-          <a:p>
-            <a:pPr lvl="1"/>
-            <a:r>
-              <a:t>Search the web (DuckDuckGo) for those phrases.</a:t>
-            </a:r>
-          </a:p>
-          <a:p>
-            <a:pPr lvl="1"/>
-            <a:r>
-              <a:t>Visit top search results and read the text (BeautifulSoup).</a:t>
-            </a:r>
-          </a:p>
-          <a:p>
-            <a:pPr lvl="1"/>
-            <a:r>
-              <a:t>Compare internet text to the student's work using similarity engine.</a:t>
-            </a:r>
-          </a:p>
-        </p:txBody>
-      </p:sp>
-    </p:spTree>
-  </p:cSld>
-  <p:clrMapOvr>
-    <a:masterClrMapping/>
-  </p:clrMapOvr>
-</p:sld>
-</file>
-
-<file path=ppt/slides/slide8.xml><?xml version="1.0" encoding="utf-8"?>
-<p:sld xmlns:a="http://schemas.openxmlformats.org/drawingml/2006/main" xmlns:p="http://schemas.openxmlformats.org/presentationml/2006/main" xmlns:r="http://schemas.openxmlformats.org/officeDocument/2006/relationships">
-  <p:cSld>
-    <p:spTree>
-      <p:nvGrpSpPr>
-        <p:cNvPr id="1" name=""/>
-        <p:cNvGrpSpPr/>
-        <p:nvPr/>
-      </p:nvGrpSpPr>
-      <p:grpSpPr/>
-      <p:sp>
-        <p:nvSpPr>
-          <p:cNvPr id="2" name="Title 1"/>
-          <p:cNvSpPr>
-            <a:spLocks noGrp="1"/>
-          </p:cNvSpPr>
-          <p:nvPr>
-            <p:ph type="title"/>
-          </p:nvPr>
-        </p:nvSpPr>
-        <p:spPr/>
-        <p:txBody>
-          <a:bodyPr/>
-          <a:lstStyle/>
-          <a:p>
-            <a:r>
-              <a:t>Challenges &amp; Solutions</a:t>
-            </a:r>
-          </a:p>
-        </p:txBody>
-      </p:sp>
-      <p:sp>
-        <p:nvSpPr>
-          <p:cNvPr id="3" name="Content Placeholder 2"/>
-          <p:cNvSpPr>
-            <a:spLocks noGrp="1"/>
-          </p:cNvSpPr>
-          <p:nvPr>
-            <p:ph idx="1"/>
-          </p:nvPr>
-        </p:nvSpPr>
-        <p:spPr/>
-        <p:txBody>
-          <a:bodyPr/>
-          <a:lstStyle/>
-          <a:p>
-            <a:r>
-              <a:t>Challenge: Reading text from scanned images or photos.</a:t>
-            </a:r>
-          </a:p>
-          <a:p>
-            <a:pPr lvl="1"/>
-            <a:r>
-              <a:t>Solution: Integrated Tesseract OCR to automatically read and extract text.</a:t>
-            </a:r>
-          </a:p>
-          <a:p>
-            <a:pPr/>
-            <a:r>
-              <a:t>Challenge: Standard search engines block automated web scraping.</a:t>
-            </a:r>
-          </a:p>
-          <a:p>
-            <a:pPr lvl="1"/>
-            <a:r>
-              <a:t>Solution: Used secure search endpoints and simple web scrapers to safely read pages.</a:t>
-            </a:r>
-          </a:p>
-          <a:p>
-            <a:pPr/>
-            <a:r>
-              <a:t>Challenge: Privacy concerns with user data.</a:t>
-            </a:r>
-          </a:p>
-          <a:p>
-            <a:pPr lvl="1"/>
-            <a:r>
-              <a:t>Solution: Designed system to process everything in system memory.</a:t>
-            </a:r>
-          </a:p>
-        </p:txBody>
-      </p:sp>
-    </p:spTree>
-  </p:cSld>
-  <p:clrMapOvr>
-    <a:masterClrMapping/>
-  </p:clrMapOvr>
-</p:sld>
-</file>
-
-<file path=ppt/slides/slide9.xml><?xml version="1.0" encoding="utf-8"?>
-<p:sld xmlns:a="http://schemas.openxmlformats.org/drawingml/2006/main" xmlns:p="http://schemas.openxmlformats.org/presentationml/2006/main" xmlns:r="http://schemas.openxmlformats.org/officeDocument/2006/relationships">
-  <p:cSld>
-    <p:spTree>
-      <p:nvGrpSpPr>
-        <p:cNvPr id="1" name=""/>
-        <p:cNvGrpSpPr/>
-        <p:nvPr/>
-      </p:nvGrpSpPr>
-      <p:grpSpPr/>
-      <p:sp>
-        <p:nvSpPr>
-          <p:cNvPr id="2" name="Title 1"/>
-          <p:cNvSpPr>
-            <a:spLocks noGrp="1"/>
-          </p:cNvSpPr>
-          <p:nvPr>
-            <p:ph type="title"/>
-          </p:nvPr>
-        </p:nvSpPr>
-        <p:spPr/>
-        <p:txBody>
-          <a:bodyPr/>
-          <a:lstStyle/>
-          <a:p>
-            <a:r>
-              <a:t>Remaining Work</a:t>
-            </a:r>
-          </a:p>
-        </p:txBody>
-      </p:sp>
-      <p:sp>
-        <p:nvSpPr>
-          <p:cNvPr id="3" name="Content Placeholder 2"/>
-          <p:cNvSpPr>
-            <a:spLocks noGrp="1"/>
-          </p:cNvSpPr>
-          <p:nvPr>
-            <p:ph idx="1"/>
-          </p:nvPr>
-        </p:nvSpPr>
-        <p:spPr/>
-        <p:txBody>
-          <a:bodyPr/>
-          <a:lstStyle/>
-          <a:p>
-            <a:r>
-              <a:t>Add support for larger documents by splitting them into smaller chunks.</a:t>
-            </a:r>
-          </a:p>
-          <a:p>
-            <a:pPr/>
-            <a:r>
-              <a:t>Polish the User Interface to make similarity matrix easier to read on small screens.</a:t>
-            </a:r>
-          </a:p>
-          <a:p>
-            <a:pPr/>
-            <a:r>
-              <a:t>Add support for checking texts in Devanagari (Nepali).</a:t>
-            </a:r>
-          </a:p>
-          <a:p>
-            <a:pPr/>
-            <a:r>
-              <a:t>Final testing and bug fixing before final submission.</a:t>
+            <p:ph type="ctrTitle"/>
+          </p:nvPr>
+        </p:nvSpPr>
+        <p:spPr/>
+        <p:txBody>
+          <a:bodyPr/>
+          <a:lstStyle/>
+          <a:p>
+            <a:r>
+              <a:t>Thank You!</a:t>
+            </a:r>
+          </a:p>
+        </p:txBody>
+      </p:sp>
+      <p:sp>
+        <p:nvSpPr>
+          <p:cNvPr id="3" name="Subtitle 2"/>
+          <p:cNvSpPr>
+            <a:spLocks noGrp="1"/>
+          </p:cNvSpPr>
+          <p:nvPr>
+            <p:ph type="subTitle" idx="1"/>
+          </p:nvPr>
+        </p:nvSpPr>
+        <p:spPr/>
+        <p:txBody>
+          <a:bodyPr/>
+          <a:lstStyle/>
+          <a:p>
+            <a:r>
+              <a:t>Questions &amp; Feedback?</a:t>
             </a:r>
           </a:p>
         </p:txBody>

</xml_diff>

<commit_message>
Add the defence presentation and update the completion slides
</commit_message>
<xml_diff>
--- a/Plagiarism_Detector_Presentation.pptx
+++ b/Plagiarism_Detector_Presentation.pptx
@@ -5,12 +5,25 @@
     <p:sldMasterId id="2147483648" r:id="rId1"/>
   </p:sldMasterIdLst>
   <p:sldIdLst>
-    <p:sldId id="256" r:id="rId2"/>
-    <p:sldId id="257" r:id="rId3"/>
-    <p:sldId id="258" r:id="rId4"/>
-    <p:sldId id="259" r:id="rId5"/>
-    <p:sldId id="260" r:id="rId6"/>
-    <p:sldId id="261" r:id="rId7"/>
+    <p:sldId id="256" r:id="rId7"/>
+    <p:sldId id="257" r:id="rId8"/>
+    <p:sldId id="258" r:id="rId9"/>
+    <p:sldId id="259" r:id="rId10"/>
+    <p:sldId id="260" r:id="rId11"/>
+    <p:sldId id="261" r:id="rId12"/>
+    <p:sldId id="262" r:id="rId13"/>
+    <p:sldId id="263" r:id="rId14"/>
+    <p:sldId id="264" r:id="rId15"/>
+    <p:sldId id="265" r:id="rId16"/>
+    <p:sldId id="266" r:id="rId17"/>
+    <p:sldId id="267" r:id="rId18"/>
+    <p:sldId id="268" r:id="rId19"/>
+    <p:sldId id="269" r:id="rId20"/>
+    <p:sldId id="270" r:id="rId21"/>
+    <p:sldId id="271" r:id="rId22"/>
+    <p:sldId id="272" r:id="rId23"/>
+    <p:sldId id="273" r:id="rId24"/>
+    <p:sldId id="274" r:id="rId25"/>
   </p:sldIdLst>
   <p:sldSz cx="9144000" cy="6858000" type="screen4x3"/>
   <p:notesSz cx="6858000" cy="9144000"/>
@@ -109,22 +122,6 @@
       </a:defRPr>
     </a:lvl9pPr>
   </p:defaultTextStyle>
-  <p:extLst>
-    <p:ext uri="{EFAFB233-063F-42B5-8137-9DF3F51BA10A}">
-      <p15:sldGuideLst xmlns:p15="http://schemas.microsoft.com/office/powerpoint/2012/main">
-        <p15:guide id="1" orient="horz" pos="2160">
-          <p15:clr>
-            <a:srgbClr val="A4A3A4"/>
-          </p15:clr>
-        </p15:guide>
-        <p15:guide id="2" pos="2880">
-          <p15:clr>
-            <a:srgbClr val="A4A3A4"/>
-          </p15:clr>
-        </p15:guide>
-      </p15:sldGuideLst>
-    </p:ext>
-  </p:extLst>
 </p:presentation>
 </file>
 
@@ -166,9 +163,10 @@
           <a:lstStyle/>
           <a:p>
             <a:r>
-              <a:rPr lang="en-US"/>
+              <a:rPr lang="en-US" smtClean="0"/>
               <a:t>Click to edit Master title style</a:t>
             </a:r>
+            <a:endParaRPr lang="en-US"/>
           </a:p>
         </p:txBody>
       </p:sp>
@@ -284,9 +282,10 @@
           </a:lstStyle>
           <a:p>
             <a:r>
-              <a:rPr lang="en-US"/>
+              <a:rPr lang="en-US" smtClean="0"/>
               <a:t>Click to edit Master subtitle style</a:t>
             </a:r>
+            <a:endParaRPr lang="en-US"/>
           </a:p>
         </p:txBody>
       </p:sp>
@@ -307,7 +306,7 @@
           <a:p>
             <a:fld id="{5BCAD085-E8A6-8845-BD4E-CB4CCA059FC4}" type="datetimeFigureOut">
               <a:rPr lang="en-US" smtClean="0"/>
-              <a:t>7/28/2026</a:t>
+              <a:t>1/27/13</a:t>
             </a:fld>
             <a:endParaRPr lang="en-US"/>
           </a:p>
@@ -401,9 +400,10 @@
           <a:lstStyle/>
           <a:p>
             <a:r>
-              <a:rPr lang="en-US"/>
+              <a:rPr lang="en-US" smtClean="0"/>
               <a:t>Click to edit Master title style</a:t>
             </a:r>
+            <a:endParaRPr lang="en-US"/>
           </a:p>
         </p:txBody>
       </p:sp>
@@ -424,37 +424,38 @@
           <a:p>
             <a:pPr lvl="0"/>
             <a:r>
-              <a:rPr lang="en-US"/>
+              <a:rPr lang="en-US" smtClean="0"/>
               <a:t>Click to edit Master text styles</a:t>
             </a:r>
           </a:p>
           <a:p>
             <a:pPr lvl="1"/>
             <a:r>
-              <a:rPr lang="en-US"/>
+              <a:rPr lang="en-US" smtClean="0"/>
               <a:t>Second level</a:t>
             </a:r>
           </a:p>
           <a:p>
             <a:pPr lvl="2"/>
             <a:r>
-              <a:rPr lang="en-US"/>
+              <a:rPr lang="en-US" smtClean="0"/>
               <a:t>Third level</a:t>
             </a:r>
           </a:p>
           <a:p>
             <a:pPr lvl="3"/>
             <a:r>
-              <a:rPr lang="en-US"/>
+              <a:rPr lang="en-US" smtClean="0"/>
               <a:t>Fourth level</a:t>
             </a:r>
           </a:p>
           <a:p>
             <a:pPr lvl="4"/>
             <a:r>
-              <a:rPr lang="en-US"/>
+              <a:rPr lang="en-US" smtClean="0"/>
               <a:t>Fifth level</a:t>
             </a:r>
+            <a:endParaRPr lang="en-US"/>
           </a:p>
         </p:txBody>
       </p:sp>
@@ -475,7 +476,7 @@
           <a:p>
             <a:fld id="{5BCAD085-E8A6-8845-BD4E-CB4CCA059FC4}" type="datetimeFigureOut">
               <a:rPr lang="en-US" smtClean="0"/>
-              <a:t>7/28/2026</a:t>
+              <a:t>1/27/13</a:t>
             </a:fld>
             <a:endParaRPr lang="en-US"/>
           </a:p>
@@ -574,9 +575,10 @@
           <a:lstStyle/>
           <a:p>
             <a:r>
-              <a:rPr lang="en-US"/>
+              <a:rPr lang="en-US" smtClean="0"/>
               <a:t>Click to edit Master title style</a:t>
             </a:r>
+            <a:endParaRPr lang="en-US"/>
           </a:p>
         </p:txBody>
       </p:sp>
@@ -602,37 +604,38 @@
           <a:p>
             <a:pPr lvl="0"/>
             <a:r>
-              <a:rPr lang="en-US"/>
+              <a:rPr lang="en-US" smtClean="0"/>
               <a:t>Click to edit Master text styles</a:t>
             </a:r>
           </a:p>
           <a:p>
             <a:pPr lvl="1"/>
             <a:r>
-              <a:rPr lang="en-US"/>
+              <a:rPr lang="en-US" smtClean="0"/>
               <a:t>Second level</a:t>
             </a:r>
           </a:p>
           <a:p>
             <a:pPr lvl="2"/>
             <a:r>
-              <a:rPr lang="en-US"/>
+              <a:rPr lang="en-US" smtClean="0"/>
               <a:t>Third level</a:t>
             </a:r>
           </a:p>
           <a:p>
             <a:pPr lvl="3"/>
             <a:r>
-              <a:rPr lang="en-US"/>
+              <a:rPr lang="en-US" smtClean="0"/>
               <a:t>Fourth level</a:t>
             </a:r>
           </a:p>
           <a:p>
             <a:pPr lvl="4"/>
             <a:r>
-              <a:rPr lang="en-US"/>
+              <a:rPr lang="en-US" smtClean="0"/>
               <a:t>Fifth level</a:t>
             </a:r>
+            <a:endParaRPr lang="en-US"/>
           </a:p>
         </p:txBody>
       </p:sp>
@@ -653,7 +656,7 @@
           <a:p>
             <a:fld id="{5BCAD085-E8A6-8845-BD4E-CB4CCA059FC4}" type="datetimeFigureOut">
               <a:rPr lang="en-US" smtClean="0"/>
-              <a:t>7/28/2026</a:t>
+              <a:t>1/27/13</a:t>
             </a:fld>
             <a:endParaRPr lang="en-US"/>
           </a:p>
@@ -747,9 +750,10 @@
           <a:lstStyle/>
           <a:p>
             <a:r>
-              <a:rPr lang="en-US"/>
+              <a:rPr lang="en-US" smtClean="0"/>
               <a:t>Click to edit Master title style</a:t>
             </a:r>
+            <a:endParaRPr lang="en-US"/>
           </a:p>
         </p:txBody>
       </p:sp>
@@ -770,37 +774,38 @@
           <a:p>
             <a:pPr lvl="0"/>
             <a:r>
-              <a:rPr lang="en-US"/>
+              <a:rPr lang="en-US" smtClean="0"/>
               <a:t>Click to edit Master text styles</a:t>
             </a:r>
           </a:p>
           <a:p>
             <a:pPr lvl="1"/>
             <a:r>
-              <a:rPr lang="en-US"/>
+              <a:rPr lang="en-US" smtClean="0"/>
               <a:t>Second level</a:t>
             </a:r>
           </a:p>
           <a:p>
             <a:pPr lvl="2"/>
             <a:r>
-              <a:rPr lang="en-US"/>
+              <a:rPr lang="en-US" smtClean="0"/>
               <a:t>Third level</a:t>
             </a:r>
           </a:p>
           <a:p>
             <a:pPr lvl="3"/>
             <a:r>
-              <a:rPr lang="en-US"/>
+              <a:rPr lang="en-US" smtClean="0"/>
               <a:t>Fourth level</a:t>
             </a:r>
           </a:p>
           <a:p>
             <a:pPr lvl="4"/>
             <a:r>
-              <a:rPr lang="en-US"/>
+              <a:rPr lang="en-US" smtClean="0"/>
               <a:t>Fifth level</a:t>
             </a:r>
+            <a:endParaRPr lang="en-US"/>
           </a:p>
         </p:txBody>
       </p:sp>
@@ -821,7 +826,7 @@
           <a:p>
             <a:fld id="{5BCAD085-E8A6-8845-BD4E-CB4CCA059FC4}" type="datetimeFigureOut">
               <a:rPr lang="en-US" smtClean="0"/>
-              <a:t>7/28/2026</a:t>
+              <a:t>1/27/13</a:t>
             </a:fld>
             <a:endParaRPr lang="en-US"/>
           </a:p>
@@ -924,9 +929,10 @@
           </a:lstStyle>
           <a:p>
             <a:r>
-              <a:rPr lang="en-US"/>
+              <a:rPr lang="en-US" smtClean="0"/>
               <a:t>Click to edit Master title style</a:t>
             </a:r>
+            <a:endParaRPr lang="en-US"/>
           </a:p>
         </p:txBody>
       </p:sp>
@@ -1043,7 +1049,7 @@
           <a:p>
             <a:pPr lvl="0"/>
             <a:r>
-              <a:rPr lang="en-US"/>
+              <a:rPr lang="en-US" smtClean="0"/>
               <a:t>Click to edit Master text styles</a:t>
             </a:r>
           </a:p>
@@ -1066,7 +1072,7 @@
           <a:p>
             <a:fld id="{5BCAD085-E8A6-8845-BD4E-CB4CCA059FC4}" type="datetimeFigureOut">
               <a:rPr lang="en-US" smtClean="0"/>
-              <a:t>7/28/2026</a:t>
+              <a:t>1/27/13</a:t>
             </a:fld>
             <a:endParaRPr lang="en-US"/>
           </a:p>
@@ -1160,9 +1166,10 @@
           <a:lstStyle/>
           <a:p>
             <a:r>
-              <a:rPr lang="en-US"/>
+              <a:rPr lang="en-US" smtClean="0"/>
               <a:t>Click to edit Master title style</a:t>
             </a:r>
+            <a:endParaRPr lang="en-US"/>
           </a:p>
         </p:txBody>
       </p:sp>
@@ -1216,37 +1223,38 @@
           <a:p>
             <a:pPr lvl="0"/>
             <a:r>
-              <a:rPr lang="en-US"/>
+              <a:rPr lang="en-US" smtClean="0"/>
               <a:t>Click to edit Master text styles</a:t>
             </a:r>
           </a:p>
           <a:p>
             <a:pPr lvl="1"/>
             <a:r>
-              <a:rPr lang="en-US"/>
+              <a:rPr lang="en-US" smtClean="0"/>
               <a:t>Second level</a:t>
             </a:r>
           </a:p>
           <a:p>
             <a:pPr lvl="2"/>
             <a:r>
-              <a:rPr lang="en-US"/>
+              <a:rPr lang="en-US" smtClean="0"/>
               <a:t>Third level</a:t>
             </a:r>
           </a:p>
           <a:p>
             <a:pPr lvl="3"/>
             <a:r>
-              <a:rPr lang="en-US"/>
+              <a:rPr lang="en-US" smtClean="0"/>
               <a:t>Fourth level</a:t>
             </a:r>
           </a:p>
           <a:p>
             <a:pPr lvl="4"/>
             <a:r>
-              <a:rPr lang="en-US"/>
+              <a:rPr lang="en-US" smtClean="0"/>
               <a:t>Fifth level</a:t>
             </a:r>
+            <a:endParaRPr lang="en-US"/>
           </a:p>
         </p:txBody>
       </p:sp>
@@ -1300,37 +1308,38 @@
           <a:p>
             <a:pPr lvl="0"/>
             <a:r>
-              <a:rPr lang="en-US"/>
+              <a:rPr lang="en-US" smtClean="0"/>
               <a:t>Click to edit Master text styles</a:t>
             </a:r>
           </a:p>
           <a:p>
             <a:pPr lvl="1"/>
             <a:r>
-              <a:rPr lang="en-US"/>
+              <a:rPr lang="en-US" smtClean="0"/>
               <a:t>Second level</a:t>
             </a:r>
           </a:p>
           <a:p>
             <a:pPr lvl="2"/>
             <a:r>
-              <a:rPr lang="en-US"/>
+              <a:rPr lang="en-US" smtClean="0"/>
               <a:t>Third level</a:t>
             </a:r>
           </a:p>
           <a:p>
             <a:pPr lvl="3"/>
             <a:r>
-              <a:rPr lang="en-US"/>
+              <a:rPr lang="en-US" smtClean="0"/>
               <a:t>Fourth level</a:t>
             </a:r>
           </a:p>
           <a:p>
             <a:pPr lvl="4"/>
             <a:r>
-              <a:rPr lang="en-US"/>
+              <a:rPr lang="en-US" smtClean="0"/>
               <a:t>Fifth level</a:t>
             </a:r>
+            <a:endParaRPr lang="en-US"/>
           </a:p>
         </p:txBody>
       </p:sp>
@@ -1351,7 +1360,7 @@
           <a:p>
             <a:fld id="{5BCAD085-E8A6-8845-BD4E-CB4CCA059FC4}" type="datetimeFigureOut">
               <a:rPr lang="en-US" smtClean="0"/>
-              <a:t>7/28/2026</a:t>
+              <a:t>1/27/13</a:t>
             </a:fld>
             <a:endParaRPr lang="en-US"/>
           </a:p>
@@ -1449,9 +1458,10 @@
           </a:lstStyle>
           <a:p>
             <a:r>
-              <a:rPr lang="en-US"/>
+              <a:rPr lang="en-US" smtClean="0"/>
               <a:t>Click to edit Master title style</a:t>
             </a:r>
+            <a:endParaRPr lang="en-US"/>
           </a:p>
         </p:txBody>
       </p:sp>
@@ -1514,7 +1524,7 @@
           <a:p>
             <a:pPr lvl="0"/>
             <a:r>
-              <a:rPr lang="en-US"/>
+              <a:rPr lang="en-US" smtClean="0"/>
               <a:t>Click to edit Master text styles</a:t>
             </a:r>
           </a:p>
@@ -1570,37 +1580,38 @@
           <a:p>
             <a:pPr lvl="0"/>
             <a:r>
-              <a:rPr lang="en-US"/>
+              <a:rPr lang="en-US" smtClean="0"/>
               <a:t>Click to edit Master text styles</a:t>
             </a:r>
           </a:p>
           <a:p>
             <a:pPr lvl="1"/>
             <a:r>
-              <a:rPr lang="en-US"/>
+              <a:rPr lang="en-US" smtClean="0"/>
               <a:t>Second level</a:t>
             </a:r>
           </a:p>
           <a:p>
             <a:pPr lvl="2"/>
             <a:r>
-              <a:rPr lang="en-US"/>
+              <a:rPr lang="en-US" smtClean="0"/>
               <a:t>Third level</a:t>
             </a:r>
           </a:p>
           <a:p>
             <a:pPr lvl="3"/>
             <a:r>
-              <a:rPr lang="en-US"/>
+              <a:rPr lang="en-US" smtClean="0"/>
               <a:t>Fourth level</a:t>
             </a:r>
           </a:p>
           <a:p>
             <a:pPr lvl="4"/>
             <a:r>
-              <a:rPr lang="en-US"/>
+              <a:rPr lang="en-US" smtClean="0"/>
               <a:t>Fifth level</a:t>
             </a:r>
+            <a:endParaRPr lang="en-US"/>
           </a:p>
         </p:txBody>
       </p:sp>
@@ -1663,7 +1674,7 @@
           <a:p>
             <a:pPr lvl="0"/>
             <a:r>
-              <a:rPr lang="en-US"/>
+              <a:rPr lang="en-US" smtClean="0"/>
               <a:t>Click to edit Master text styles</a:t>
             </a:r>
           </a:p>
@@ -1719,37 +1730,38 @@
           <a:p>
             <a:pPr lvl="0"/>
             <a:r>
-              <a:rPr lang="en-US"/>
+              <a:rPr lang="en-US" smtClean="0"/>
               <a:t>Click to edit Master text styles</a:t>
             </a:r>
           </a:p>
           <a:p>
             <a:pPr lvl="1"/>
             <a:r>
-              <a:rPr lang="en-US"/>
+              <a:rPr lang="en-US" smtClean="0"/>
               <a:t>Second level</a:t>
             </a:r>
           </a:p>
           <a:p>
             <a:pPr lvl="2"/>
             <a:r>
-              <a:rPr lang="en-US"/>
+              <a:rPr lang="en-US" smtClean="0"/>
               <a:t>Third level</a:t>
             </a:r>
           </a:p>
           <a:p>
             <a:pPr lvl="3"/>
             <a:r>
-              <a:rPr lang="en-US"/>
+              <a:rPr lang="en-US" smtClean="0"/>
               <a:t>Fourth level</a:t>
             </a:r>
           </a:p>
           <a:p>
             <a:pPr lvl="4"/>
             <a:r>
-              <a:rPr lang="en-US"/>
+              <a:rPr lang="en-US" smtClean="0"/>
               <a:t>Fifth level</a:t>
             </a:r>
+            <a:endParaRPr lang="en-US"/>
           </a:p>
         </p:txBody>
       </p:sp>
@@ -1770,7 +1782,7 @@
           <a:p>
             <a:fld id="{5BCAD085-E8A6-8845-BD4E-CB4CCA059FC4}" type="datetimeFigureOut">
               <a:rPr lang="en-US" smtClean="0"/>
-              <a:t>7/28/2026</a:t>
+              <a:t>1/27/13</a:t>
             </a:fld>
             <a:endParaRPr lang="en-US"/>
           </a:p>
@@ -1864,9 +1876,10 @@
           <a:lstStyle/>
           <a:p>
             <a:r>
-              <a:rPr lang="en-US"/>
+              <a:rPr lang="en-US" smtClean="0"/>
               <a:t>Click to edit Master title style</a:t>
             </a:r>
+            <a:endParaRPr lang="en-US"/>
           </a:p>
         </p:txBody>
       </p:sp>
@@ -1887,7 +1900,7 @@
           <a:p>
             <a:fld id="{5BCAD085-E8A6-8845-BD4E-CB4CCA059FC4}" type="datetimeFigureOut">
               <a:rPr lang="en-US" smtClean="0"/>
-              <a:t>7/28/2026</a:t>
+              <a:t>1/27/13</a:t>
             </a:fld>
             <a:endParaRPr lang="en-US"/>
           </a:p>
@@ -1982,7 +1995,7 @@
           <a:p>
             <a:fld id="{5BCAD085-E8A6-8845-BD4E-CB4CCA059FC4}" type="datetimeFigureOut">
               <a:rPr lang="en-US" smtClean="0"/>
-              <a:t>7/28/2026</a:t>
+              <a:t>1/27/13</a:t>
             </a:fld>
             <a:endParaRPr lang="en-US"/>
           </a:p>
@@ -2085,9 +2098,10 @@
           </a:lstStyle>
           <a:p>
             <a:r>
-              <a:rPr lang="en-US"/>
+              <a:rPr lang="en-US" smtClean="0"/>
               <a:t>Click to edit Master title style</a:t>
             </a:r>
+            <a:endParaRPr lang="en-US"/>
           </a:p>
         </p:txBody>
       </p:sp>
@@ -2141,37 +2155,38 @@
           <a:p>
             <a:pPr lvl="0"/>
             <a:r>
-              <a:rPr lang="en-US"/>
+              <a:rPr lang="en-US" smtClean="0"/>
               <a:t>Click to edit Master text styles</a:t>
             </a:r>
           </a:p>
           <a:p>
             <a:pPr lvl="1"/>
             <a:r>
-              <a:rPr lang="en-US"/>
+              <a:rPr lang="en-US" smtClean="0"/>
               <a:t>Second level</a:t>
             </a:r>
           </a:p>
           <a:p>
             <a:pPr lvl="2"/>
             <a:r>
-              <a:rPr lang="en-US"/>
+              <a:rPr lang="en-US" smtClean="0"/>
               <a:t>Third level</a:t>
             </a:r>
           </a:p>
           <a:p>
             <a:pPr lvl="3"/>
             <a:r>
-              <a:rPr lang="en-US"/>
+              <a:rPr lang="en-US" smtClean="0"/>
               <a:t>Fourth level</a:t>
             </a:r>
           </a:p>
           <a:p>
             <a:pPr lvl="4"/>
             <a:r>
-              <a:rPr lang="en-US"/>
+              <a:rPr lang="en-US" smtClean="0"/>
               <a:t>Fifth level</a:t>
             </a:r>
+            <a:endParaRPr lang="en-US"/>
           </a:p>
         </p:txBody>
       </p:sp>
@@ -2234,7 +2249,7 @@
           <a:p>
             <a:pPr lvl="0"/>
             <a:r>
-              <a:rPr lang="en-US"/>
+              <a:rPr lang="en-US" smtClean="0"/>
               <a:t>Click to edit Master text styles</a:t>
             </a:r>
           </a:p>
@@ -2257,7 +2272,7 @@
           <a:p>
             <a:fld id="{5BCAD085-E8A6-8845-BD4E-CB4CCA059FC4}" type="datetimeFigureOut">
               <a:rPr lang="en-US" smtClean="0"/>
-              <a:t>7/28/2026</a:t>
+              <a:t>1/27/13</a:t>
             </a:fld>
             <a:endParaRPr lang="en-US"/>
           </a:p>
@@ -2360,9 +2375,10 @@
           </a:lstStyle>
           <a:p>
             <a:r>
-              <a:rPr lang="en-US"/>
+              <a:rPr lang="en-US" smtClean="0"/>
               <a:t>Click to edit Master title style</a:t>
             </a:r>
+            <a:endParaRPr lang="en-US"/>
           </a:p>
         </p:txBody>
       </p:sp>
@@ -2486,7 +2502,7 @@
           <a:p>
             <a:pPr lvl="0"/>
             <a:r>
-              <a:rPr lang="en-US"/>
+              <a:rPr lang="en-US" smtClean="0"/>
               <a:t>Click to edit Master text styles</a:t>
             </a:r>
           </a:p>
@@ -2509,7 +2525,7 @@
           <a:p>
             <a:fld id="{5BCAD085-E8A6-8845-BD4E-CB4CCA059FC4}" type="datetimeFigureOut">
               <a:rPr lang="en-US" smtClean="0"/>
-              <a:t>7/28/2026</a:t>
+              <a:t>1/27/13</a:t>
             </a:fld>
             <a:endParaRPr lang="en-US"/>
           </a:p>
@@ -2618,9 +2634,10 @@
           <a:lstStyle/>
           <a:p>
             <a:r>
-              <a:rPr lang="en-US"/>
+              <a:rPr lang="en-US" smtClean="0"/>
               <a:t>Click to edit Master title style</a:t>
             </a:r>
+            <a:endParaRPr lang="en-US"/>
           </a:p>
         </p:txBody>
       </p:sp>
@@ -2651,37 +2668,38 @@
           <a:p>
             <a:pPr lvl="0"/>
             <a:r>
-              <a:rPr lang="en-US"/>
+              <a:rPr lang="en-US" smtClean="0"/>
               <a:t>Click to edit Master text styles</a:t>
             </a:r>
           </a:p>
           <a:p>
             <a:pPr lvl="1"/>
             <a:r>
-              <a:rPr lang="en-US"/>
+              <a:rPr lang="en-US" smtClean="0"/>
               <a:t>Second level</a:t>
             </a:r>
           </a:p>
           <a:p>
             <a:pPr lvl="2"/>
             <a:r>
-              <a:rPr lang="en-US"/>
+              <a:rPr lang="en-US" smtClean="0"/>
               <a:t>Third level</a:t>
             </a:r>
           </a:p>
           <a:p>
             <a:pPr lvl="3"/>
             <a:r>
-              <a:rPr lang="en-US"/>
+              <a:rPr lang="en-US" smtClean="0"/>
               <a:t>Fourth level</a:t>
             </a:r>
           </a:p>
           <a:p>
             <a:pPr lvl="4"/>
             <a:r>
-              <a:rPr lang="en-US"/>
+              <a:rPr lang="en-US" smtClean="0"/>
               <a:t>Fifth level</a:t>
             </a:r>
+            <a:endParaRPr lang="en-US"/>
           </a:p>
         </p:txBody>
       </p:sp>
@@ -2720,7 +2738,7 @@
           <a:p>
             <a:fld id="{5BCAD085-E8A6-8845-BD4E-CB4CCA059FC4}" type="datetimeFigureOut">
               <a:rPr lang="en-US" smtClean="0"/>
-              <a:t>7/28/2026</a:t>
+              <a:t>1/27/13</a:t>
             </a:fld>
             <a:endParaRPr lang="en-US"/>
           </a:p>
@@ -3079,7 +3097,7 @@
 </file>
 
 <file path=ppt/slides/slide1.xml><?xml version="1.0" encoding="utf-8"?>
-<p:sld xmlns:a="http://schemas.openxmlformats.org/drawingml/2006/main" xmlns:r="http://schemas.openxmlformats.org/officeDocument/2006/relationships" xmlns:p="http://schemas.openxmlformats.org/presentationml/2006/main">
+<p:sld xmlns:a="http://schemas.openxmlformats.org/drawingml/2006/main" xmlns:p="http://schemas.openxmlformats.org/presentationml/2006/main" xmlns:r="http://schemas.openxmlformats.org/officeDocument/2006/relationships">
   <p:cSld>
     <p:spTree>
       <p:nvGrpSpPr>
@@ -3087,14 +3105,7 @@
         <p:cNvGrpSpPr/>
         <p:nvPr/>
       </p:nvGrpSpPr>
-      <p:grpSpPr>
-        <a:xfrm>
-          <a:off x="0" y="0"/>
-          <a:ext cx="0" cy="0"/>
-          <a:chOff x="0" y="0"/>
-          <a:chExt cx="0" cy="0"/>
-        </a:xfrm>
-      </p:grpSpPr>
+      <p:grpSpPr/>
       <p:sp>
         <p:nvSpPr>
           <p:cNvPr id="2" name="Title 1"/>
@@ -3104,158 +3115,1860 @@
           <p:nvPr>
             <p:ph type="ctrTitle"/>
           </p:nvPr>
+        </p:nvSpPr>
+        <p:spPr/>
+        <p:txBody>
+          <a:bodyPr/>
+          <a:lstStyle/>
+          <a:p>
+            <a:r>
+              <a:t>Plagiarism Detector</a:t>
+            </a:r>
+          </a:p>
+        </p:txBody>
+      </p:sp>
+      <p:sp>
+        <p:nvSpPr>
+          <p:cNvPr id="3" name="Subtitle 2"/>
+          <p:cNvSpPr>
+            <a:spLocks noGrp="1"/>
+          </p:cNvSpPr>
+          <p:nvPr>
+            <p:ph type="subTitle" idx="1"/>
+          </p:nvPr>
+        </p:nvSpPr>
+        <p:spPr/>
+        <p:txBody>
+          <a:bodyPr/>
+          <a:lstStyle/>
+          <a:p>
+            <a:r>
+              <a:t>Minor II Project Completion Presentation</a:t>
+            </a:r>
+          </a:p>
+          <a:p/>
+          <a:p>
+            <a:r>
+              <a:t>Gandaki College of Engineering and Science</a:t>
+            </a:r>
+          </a:p>
+          <a:p/>
+          <a:p>
+            <a:r>
+              <a:t>Presented by:</a:t>
+            </a:r>
+          </a:p>
+          <a:p>
+            <a:r>
+              <a:t>Neon Neupane</a:t>
+            </a:r>
+          </a:p>
+          <a:p>
+            <a:r>
+              <a:t>Bishal Acharya</a:t>
+            </a:r>
+          </a:p>
+          <a:p>
+            <a:r>
+              <a:t>Nabin Giri</a:t>
+            </a:r>
+          </a:p>
+          <a:p/>
+          <a:p>
+            <a:r>
+              <a:t>Date: Shrawan 25, 2083</a:t>
+            </a:r>
+          </a:p>
+        </p:txBody>
+      </p:sp>
+    </p:spTree>
+  </p:cSld>
+  <p:clrMapOvr>
+    <a:masterClrMapping/>
+  </p:clrMapOvr>
+</p:sld>
+</file>
+
+<file path=ppt/slides/slide10.xml><?xml version="1.0" encoding="utf-8"?>
+<p:sld xmlns:a="http://schemas.openxmlformats.org/drawingml/2006/main" xmlns:p="http://schemas.openxmlformats.org/presentationml/2006/main" xmlns:r="http://schemas.openxmlformats.org/officeDocument/2006/relationships">
+  <p:cSld>
+    <p:spTree>
+      <p:nvGrpSpPr>
+        <p:cNvPr id="1" name=""/>
+        <p:cNvGrpSpPr/>
+        <p:nvPr/>
+      </p:nvGrpSpPr>
+      <p:grpSpPr/>
+      <p:sp>
+        <p:nvSpPr>
+          <p:cNvPr id="2" name="Title 1"/>
+          <p:cNvSpPr>
+            <a:spLocks noGrp="1"/>
+          </p:cNvSpPr>
+          <p:nvPr>
+            <p:ph type="title"/>
+          </p:nvPr>
+        </p:nvSpPr>
+        <p:spPr/>
+        <p:txBody>
+          <a:bodyPr/>
+          <a:lstStyle/>
+          <a:p>
+            <a:r>
+              <a:t>Handling Devanagari</a:t>
+            </a:r>
+          </a:p>
+        </p:txBody>
+      </p:sp>
+      <p:sp>
+        <p:nvSpPr>
+          <p:cNvPr id="3" name="Content Placeholder 2"/>
+          <p:cNvSpPr>
+            <a:spLocks noGrp="1"/>
+          </p:cNvSpPr>
+          <p:nvPr>
+            <p:ph idx="1"/>
+          </p:nvPr>
+        </p:nvSpPr>
+        <p:spPr/>
+        <p:txBody>
+          <a:bodyPr wrap="square"/>
+          <a:lstStyle/>
+          <a:p>
+            <a:pPr>
+              <a:spcAft>
+                <a:spcPts val="600"/>
+              </a:spcAft>
+            </a:pPr>
+            <a:r>
+              <a:rPr sz="1800" b="0"/>
+              <a:t>Nepali is not English in a different alphabet. Three things had to change.</a:t>
+            </a:r>
+          </a:p>
+          <a:p>
+            <a:pPr lvl="1">
+              <a:spcAft>
+                <a:spcPts val="600"/>
+              </a:spcAft>
+            </a:pPr>
+            <a:r>
+              <a:rPr sz="1500" b="0"/>
+              <a:t>A Devanagari sentence closes with the danda, and often with no space after it. The splitter now ends a sentence on that character either way.</a:t>
+            </a:r>
+          </a:p>
+          <a:p>
+            <a:pPr lvl="1">
+              <a:spcAft>
+                <a:spcPts val="600"/>
+              </a:spcAft>
+            </a:pPr>
+            <a:r>
+              <a:rPr sz="1500" b="0"/>
+              <a:t>The baseline tokenizer matched Latin letters and digits only, so it returned an empty list for Nepali and reported a similarity of zero for two identical Nepali documents. The pattern now covers the Devanagari range.</a:t>
+            </a:r>
+          </a:p>
+          <a:p>
+            <a:pPr lvl="1">
+              <a:spcAft>
+                <a:spcPts val="600"/>
+              </a:spcAft>
+            </a:pPr>
+            <a:r>
+              <a:rPr sz="1500" b="0"/>
+              <a:t>Common Nepali function words were added to the stopword list.</a:t>
+            </a:r>
+          </a:p>
+          <a:p>
+            <a:pPr lvl="1">
+              <a:spcAft>
+                <a:spcPts val="600"/>
+              </a:spcAft>
+            </a:pPr>
+            <a:r>
+              <a:rPr sz="1500" b="0"/>
+              <a:t>Tesseract uses the Nepali training data when the machine has it and falls back to English when it does not. The check runs once and is remembered.</a:t>
+            </a:r>
+          </a:p>
+        </p:txBody>
+      </p:sp>
+    </p:spTree>
+  </p:cSld>
+  <p:clrMapOvr>
+    <a:masterClrMapping/>
+  </p:clrMapOvr>
+</p:sld>
+</file>
+
+<file path=ppt/slides/slide11.xml><?xml version="1.0" encoding="utf-8"?>
+<p:sld xmlns:a="http://schemas.openxmlformats.org/drawingml/2006/main" xmlns:p="http://schemas.openxmlformats.org/presentationml/2006/main" xmlns:r="http://schemas.openxmlformats.org/officeDocument/2006/relationships">
+  <p:cSld>
+    <p:spTree>
+      <p:nvGrpSpPr>
+        <p:cNvPr id="1" name=""/>
+        <p:cNvGrpSpPr/>
+        <p:nvPr/>
+      </p:nvGrpSpPr>
+      <p:grpSpPr/>
+      <p:sp>
+        <p:nvSpPr>
+          <p:cNvPr id="2" name="Title 1"/>
+          <p:cNvSpPr>
+            <a:spLocks noGrp="1"/>
+          </p:cNvSpPr>
+          <p:nvPr>
+            <p:ph type="title"/>
+          </p:nvPr>
+        </p:nvSpPr>
+        <p:spPr/>
+        <p:txBody>
+          <a:bodyPr/>
+          <a:lstStyle/>
+          <a:p>
+            <a:r>
+              <a:t>Accuracy of the Three Engines</a:t>
+            </a:r>
+          </a:p>
+        </p:txBody>
+      </p:sp>
+      <p:graphicFrame>
+        <p:nvGraphicFramePr>
+          <p:cNvPr id="3" name="Table 2"/>
+          <p:cNvGraphicFramePr>
+            <a:graphicFrameLocks noGrp="1"/>
+          </p:cNvGraphicFramePr>
+          <p:nvPr/>
+        </p:nvGraphicFramePr>
+        <p:xfrm>
+          <a:off x="365760" y="1463040"/>
+          <a:ext cx="8412480" cy="3291840"/>
+        </p:xfrm>
+        <a:graphic>
+          <a:graphicData uri="http://schemas.openxmlformats.org/drawingml/2006/table">
+            <a:tbl>
+              <a:tblPr firstRow="1" bandRow="1">
+                <a:tableStyleId>{5C22544A-7EE6-4342-B048-85BDC9FD1C3A}</a:tableStyleId>
+              </a:tblPr>
+              <a:tblGrid>
+                <a:gridCol w="2011680"/>
+                <a:gridCol w="1828800"/>
+                <a:gridCol w="1188720"/>
+                <a:gridCol w="1188720"/>
+                <a:gridCol w="1097280"/>
+                <a:gridCol w="1097280"/>
+              </a:tblGrid>
+              <a:tr h="470262">
+                <a:tc>
+                  <a:txBody>
+                    <a:bodyPr/>
+                    <a:lstStyle/>
+                    <a:p>
+                      <a:r>
+                        <a:rPr sz="1300" b="1"/>
+                        <a:t>Evaluation set</a:t>
+                      </a:r>
+                    </a:p>
+                  </a:txBody>
+                  <a:tcPr/>
+                </a:tc>
+                <a:tc>
+                  <a:txBody>
+                    <a:bodyPr/>
+                    <a:lstStyle/>
+                    <a:p>
+                      <a:r>
+                        <a:rPr sz="1300" b="1"/>
+                        <a:t>Engine</a:t>
+                      </a:r>
+                    </a:p>
+                  </a:txBody>
+                  <a:tcPr/>
+                </a:tc>
+                <a:tc>
+                  <a:txBody>
+                    <a:bodyPr/>
+                    <a:lstStyle/>
+                    <a:p>
+                      <a:r>
+                        <a:rPr sz="1300" b="1"/>
+                        <a:t>Accuracy</a:t>
+                      </a:r>
+                    </a:p>
+                  </a:txBody>
+                  <a:tcPr/>
+                </a:tc>
+                <a:tc>
+                  <a:txBody>
+                    <a:bodyPr/>
+                    <a:lstStyle/>
+                    <a:p>
+                      <a:r>
+                        <a:rPr sz="1300" b="1"/>
+                        <a:t>Precision</a:t>
+                      </a:r>
+                    </a:p>
+                  </a:txBody>
+                  <a:tcPr/>
+                </a:tc>
+                <a:tc>
+                  <a:txBody>
+                    <a:bodyPr/>
+                    <a:lstStyle/>
+                    <a:p>
+                      <a:r>
+                        <a:rPr sz="1300" b="1"/>
+                        <a:t>Recall</a:t>
+                      </a:r>
+                    </a:p>
+                  </a:txBody>
+                  <a:tcPr/>
+                </a:tc>
+                <a:tc>
+                  <a:txBody>
+                    <a:bodyPr/>
+                    <a:lstStyle/>
+                    <a:p>
+                      <a:r>
+                        <a:rPr sz="1300" b="1"/>
+                        <a:t>F1</a:t>
+                      </a:r>
+                    </a:p>
+                  </a:txBody>
+                  <a:tcPr/>
+                </a:tc>
+              </a:tr>
+              <a:tr h="470262">
+                <a:tc>
+                  <a:txBody>
+                    <a:bodyPr/>
+                    <a:lstStyle/>
+                    <a:p>
+                      <a:r>
+                        <a:rPr sz="1300" b="0"/>
+                        <a:t>Quora validation</a:t>
+                      </a:r>
+                    </a:p>
+                    <a:p>
+                      <a:r>
+                        <a:rPr sz="1300" b="0"/>
+                        <a:t>(2000 pairs)</a:t>
+                      </a:r>
+                    </a:p>
+                  </a:txBody>
+                  <a:tcPr/>
+                </a:tc>
+                <a:tc>
+                  <a:txBody>
+                    <a:bodyPr/>
+                    <a:lstStyle/>
+                    <a:p>
+                      <a:r>
+                        <a:rPr sz="1300" b="0"/>
+                        <a:t>TF-IDF baseline</a:t>
+                      </a:r>
+                    </a:p>
+                  </a:txBody>
+                  <a:tcPr/>
+                </a:tc>
+                <a:tc>
+                  <a:txBody>
+                    <a:bodyPr/>
+                    <a:lstStyle/>
+                    <a:p>
+                      <a:r>
+                        <a:rPr sz="1300" b="0"/>
+                        <a:t>0.6665</a:t>
+                      </a:r>
+                    </a:p>
+                  </a:txBody>
+                  <a:tcPr/>
+                </a:tc>
+                <a:tc>
+                  <a:txBody>
+                    <a:bodyPr/>
+                    <a:lstStyle/>
+                    <a:p>
+                      <a:r>
+                        <a:rPr sz="1300" b="0"/>
+                        <a:t>0.5380</a:t>
+                      </a:r>
+                    </a:p>
+                  </a:txBody>
+                  <a:tcPr/>
+                </a:tc>
+                <a:tc>
+                  <a:txBody>
+                    <a:bodyPr/>
+                    <a:lstStyle/>
+                    <a:p>
+                      <a:r>
+                        <a:rPr sz="1300" b="0"/>
+                        <a:t>0.2558</a:t>
+                      </a:r>
+                    </a:p>
+                  </a:txBody>
+                  <a:tcPr/>
+                </a:tc>
+                <a:tc>
+                  <a:txBody>
+                    <a:bodyPr/>
+                    <a:lstStyle/>
+                    <a:p>
+                      <a:r>
+                        <a:rPr sz="1300" b="0"/>
+                        <a:t>0.3467</a:t>
+                      </a:r>
+                    </a:p>
+                  </a:txBody>
+                  <a:tcPr/>
+                </a:tc>
+              </a:tr>
+              <a:tr h="470262">
+                <a:tc>
+                  <a:txBody>
+                    <a:bodyPr/>
+                    <a:lstStyle/>
+                    <a:p/>
+                  </a:txBody>
+                  <a:tcPr/>
+                </a:tc>
+                <a:tc>
+                  <a:txBody>
+                    <a:bodyPr/>
+                    <a:lstStyle/>
+                    <a:p>
+                      <a:r>
+                        <a:rPr sz="1300" b="0"/>
+                        <a:t>SBERT pretrained</a:t>
+                      </a:r>
+                    </a:p>
+                  </a:txBody>
+                  <a:tcPr/>
+                </a:tc>
+                <a:tc>
+                  <a:txBody>
+                    <a:bodyPr/>
+                    <a:lstStyle/>
+                    <a:p>
+                      <a:r>
+                        <a:rPr sz="1300" b="0"/>
+                        <a:t>0.7430</a:t>
+                      </a:r>
+                    </a:p>
+                  </a:txBody>
+                  <a:tcPr/>
+                </a:tc>
+                <a:tc>
+                  <a:txBody>
+                    <a:bodyPr/>
+                    <a:lstStyle/>
+                    <a:p>
+                      <a:r>
+                        <a:rPr sz="1300" b="0"/>
+                        <a:t>0.5800</a:t>
+                      </a:r>
+                    </a:p>
+                  </a:txBody>
+                  <a:tcPr/>
+                </a:tc>
+                <a:tc>
+                  <a:txBody>
+                    <a:bodyPr/>
+                    <a:lstStyle/>
+                    <a:p>
+                      <a:r>
+                        <a:rPr sz="1300" b="0"/>
+                        <a:t>0.9321</a:t>
+                      </a:r>
+                    </a:p>
+                  </a:txBody>
+                  <a:tcPr/>
+                </a:tc>
+                <a:tc>
+                  <a:txBody>
+                    <a:bodyPr/>
+                    <a:lstStyle/>
+                    <a:p>
+                      <a:r>
+                        <a:rPr sz="1300" b="0"/>
+                        <a:t>0.7151</a:t>
+                      </a:r>
+                    </a:p>
+                  </a:txBody>
+                  <a:tcPr/>
+                </a:tc>
+              </a:tr>
+              <a:tr h="470262">
+                <a:tc>
+                  <a:txBody>
+                    <a:bodyPr/>
+                    <a:lstStyle/>
+                    <a:p/>
+                  </a:txBody>
+                  <a:tcPr/>
+                </a:tc>
+                <a:tc>
+                  <a:txBody>
+                    <a:bodyPr/>
+                    <a:lstStyle/>
+                    <a:p>
+                      <a:r>
+                        <a:rPr sz="1300" b="1"/>
+                        <a:t>SBERT fine tuned</a:t>
+                      </a:r>
+                    </a:p>
+                  </a:txBody>
+                  <a:tcPr/>
+                </a:tc>
+                <a:tc>
+                  <a:txBody>
+                    <a:bodyPr/>
+                    <a:lstStyle/>
+                    <a:p>
+                      <a:r>
+                        <a:rPr sz="1300" b="0"/>
+                        <a:t>0.8260</a:t>
+                      </a:r>
+                    </a:p>
+                  </a:txBody>
+                  <a:tcPr/>
+                </a:tc>
+                <a:tc>
+                  <a:txBody>
+                    <a:bodyPr/>
+                    <a:lstStyle/>
+                    <a:p>
+                      <a:r>
+                        <a:rPr sz="1300" b="0"/>
+                        <a:t>0.7544</a:t>
+                      </a:r>
+                    </a:p>
+                  </a:txBody>
+                  <a:tcPr/>
+                </a:tc>
+                <a:tc>
+                  <a:txBody>
+                    <a:bodyPr/>
+                    <a:lstStyle/>
+                    <a:p>
+                      <a:r>
+                        <a:rPr sz="1300" b="0"/>
+                        <a:t>0.7370</a:t>
+                      </a:r>
+                    </a:p>
+                  </a:txBody>
+                  <a:tcPr/>
+                </a:tc>
+                <a:tc>
+                  <a:txBody>
+                    <a:bodyPr/>
+                    <a:lstStyle/>
+                    <a:p>
+                      <a:r>
+                        <a:rPr sz="1300" b="0"/>
+                        <a:t>0.7456</a:t>
+                      </a:r>
+                    </a:p>
+                  </a:txBody>
+                  <a:tcPr/>
+                </a:tc>
+              </a:tr>
+              <a:tr h="470262">
+                <a:tc>
+                  <a:txBody>
+                    <a:bodyPr/>
+                    <a:lstStyle/>
+                    <a:p>
+                      <a:r>
+                        <a:rPr sz="1300" b="0"/>
+                        <a:t>MRPC validation</a:t>
+                      </a:r>
+                    </a:p>
+                    <a:p>
+                      <a:r>
+                        <a:rPr sz="1300" b="0"/>
+                        <a:t>(408 pairs, unseen)</a:t>
+                      </a:r>
+                    </a:p>
+                  </a:txBody>
+                  <a:tcPr/>
+                </a:tc>
+                <a:tc>
+                  <a:txBody>
+                    <a:bodyPr/>
+                    <a:lstStyle/>
+                    <a:p>
+                      <a:r>
+                        <a:rPr sz="1300" b="0"/>
+                        <a:t>TF-IDF baseline</a:t>
+                      </a:r>
+                    </a:p>
+                  </a:txBody>
+                  <a:tcPr/>
+                </a:tc>
+                <a:tc>
+                  <a:txBody>
+                    <a:bodyPr/>
+                    <a:lstStyle/>
+                    <a:p>
+                      <a:r>
+                        <a:rPr sz="1300" b="0"/>
+                        <a:t>0.5049</a:t>
+                      </a:r>
+                    </a:p>
+                  </a:txBody>
+                  <a:tcPr/>
+                </a:tc>
+                <a:tc>
+                  <a:txBody>
+                    <a:bodyPr/>
+                    <a:lstStyle/>
+                    <a:p>
+                      <a:r>
+                        <a:rPr sz="1300" b="0"/>
+                        <a:t>0.9326</a:t>
+                      </a:r>
+                    </a:p>
+                  </a:txBody>
+                  <a:tcPr/>
+                </a:tc>
+                <a:tc>
+                  <a:txBody>
+                    <a:bodyPr/>
+                    <a:lstStyle/>
+                    <a:p>
+                      <a:r>
+                        <a:rPr sz="1300" b="0"/>
+                        <a:t>0.2975</a:t>
+                      </a:r>
+                    </a:p>
+                  </a:txBody>
+                  <a:tcPr/>
+                </a:tc>
+                <a:tc>
+                  <a:txBody>
+                    <a:bodyPr/>
+                    <a:lstStyle/>
+                    <a:p>
+                      <a:r>
+                        <a:rPr sz="1300" b="0"/>
+                        <a:t>0.4511</a:t>
+                      </a:r>
+                    </a:p>
+                  </a:txBody>
+                  <a:tcPr/>
+                </a:tc>
+              </a:tr>
+              <a:tr h="470262">
+                <a:tc>
+                  <a:txBody>
+                    <a:bodyPr/>
+                    <a:lstStyle/>
+                    <a:p/>
+                  </a:txBody>
+                  <a:tcPr/>
+                </a:tc>
+                <a:tc>
+                  <a:txBody>
+                    <a:bodyPr/>
+                    <a:lstStyle/>
+                    <a:p>
+                      <a:r>
+                        <a:rPr sz="1300" b="0"/>
+                        <a:t>SBERT pretrained</a:t>
+                      </a:r>
+                    </a:p>
+                  </a:txBody>
+                  <a:tcPr/>
+                </a:tc>
+                <a:tc>
+                  <a:txBody>
+                    <a:bodyPr/>
+                    <a:lstStyle/>
+                    <a:p>
+                      <a:r>
+                        <a:rPr sz="1300" b="0"/>
+                        <a:t>0.7475</a:t>
+                      </a:r>
+                    </a:p>
+                  </a:txBody>
+                  <a:tcPr/>
+                </a:tc>
+                <a:tc>
+                  <a:txBody>
+                    <a:bodyPr/>
+                    <a:lstStyle/>
+                    <a:p>
+                      <a:r>
+                        <a:rPr sz="1300" b="0"/>
+                        <a:t>0.7733</a:t>
+                      </a:r>
+                    </a:p>
+                  </a:txBody>
+                  <a:tcPr/>
+                </a:tc>
+                <a:tc>
+                  <a:txBody>
+                    <a:bodyPr/>
+                    <a:lstStyle/>
+                    <a:p>
+                      <a:r>
+                        <a:rPr sz="1300" b="0"/>
+                        <a:t>0.8925</a:t>
+                      </a:r>
+                    </a:p>
+                  </a:txBody>
+                  <a:tcPr/>
+                </a:tc>
+                <a:tc>
+                  <a:txBody>
+                    <a:bodyPr/>
+                    <a:lstStyle/>
+                    <a:p>
+                      <a:r>
+                        <a:rPr sz="1300" b="0"/>
+                        <a:t>0.8286</a:t>
+                      </a:r>
+                    </a:p>
+                  </a:txBody>
+                  <a:tcPr/>
+                </a:tc>
+              </a:tr>
+              <a:tr h="470268">
+                <a:tc>
+                  <a:txBody>
+                    <a:bodyPr/>
+                    <a:lstStyle/>
+                    <a:p/>
+                  </a:txBody>
+                  <a:tcPr/>
+                </a:tc>
+                <a:tc>
+                  <a:txBody>
+                    <a:bodyPr/>
+                    <a:lstStyle/>
+                    <a:p>
+                      <a:r>
+                        <a:rPr sz="1300" b="1"/>
+                        <a:t>SBERT fine tuned</a:t>
+                      </a:r>
+                    </a:p>
+                  </a:txBody>
+                  <a:tcPr/>
+                </a:tc>
+                <a:tc>
+                  <a:txBody>
+                    <a:bodyPr/>
+                    <a:lstStyle/>
+                    <a:p>
+                      <a:r>
+                        <a:rPr sz="1300" b="0"/>
+                        <a:t>0.6691</a:t>
+                      </a:r>
+                    </a:p>
+                  </a:txBody>
+                  <a:tcPr/>
+                </a:tc>
+                <a:tc>
+                  <a:txBody>
+                    <a:bodyPr/>
+                    <a:lstStyle/>
+                    <a:p>
+                      <a:r>
+                        <a:rPr sz="1300" b="0"/>
+                        <a:t>0.8077</a:t>
+                      </a:r>
+                    </a:p>
+                  </a:txBody>
+                  <a:tcPr/>
+                </a:tc>
+                <a:tc>
+                  <a:txBody>
+                    <a:bodyPr/>
+                    <a:lstStyle/>
+                    <a:p>
+                      <a:r>
+                        <a:rPr sz="1300" b="0"/>
+                        <a:t>0.6774</a:t>
+                      </a:r>
+                    </a:p>
+                  </a:txBody>
+                  <a:tcPr/>
+                </a:tc>
+                <a:tc>
+                  <a:txBody>
+                    <a:bodyPr/>
+                    <a:lstStyle/>
+                    <a:p>
+                      <a:r>
+                        <a:rPr sz="1300" b="0"/>
+                        <a:t>0.7368</a:t>
+                      </a:r>
+                    </a:p>
+                  </a:txBody>
+                  <a:tcPr/>
+                </a:tc>
+              </a:tr>
+            </a:tbl>
+          </a:graphicData>
+        </a:graphic>
+      </p:graphicFrame>
+      <p:sp>
+        <p:nvSpPr>
+          <p:cNvPr id="4" name="TextBox 3"/>
+          <p:cNvSpPr txBox="1"/>
+          <p:nvPr/>
         </p:nvSpPr>
         <p:spPr>
           <a:xfrm>
-            <a:off x="685800" y="190306"/>
-            <a:ext cx="7772400" cy="1470025"/>
+            <a:off x="457200" y="5029200"/>
+            <a:ext cx="8229600" cy="1280160"/>
           </a:xfrm>
+          <a:prstGeom prst="rect">
+            <a:avLst/>
+          </a:prstGeom>
+          <a:noFill/>
         </p:spPr>
         <p:txBody>
-          <a:bodyPr/>
-          <a:lstStyle/>
-          <a:p>
-            <a:r>
-              <a:rPr dirty="0"/>
-              <a:t>Plagiarism Detector</a:t>
-            </a:r>
-          </a:p>
-        </p:txBody>
-      </p:sp>
-      <p:sp>
-        <p:nvSpPr>
-          <p:cNvPr id="3" name="Subtitle 2"/>
-          <p:cNvSpPr>
-            <a:spLocks noGrp="1"/>
-          </p:cNvSpPr>
-          <p:nvPr>
-            <p:ph type="subTitle" idx="1"/>
-          </p:nvPr>
+          <a:bodyPr wrap="square">
+            <a:spAutoFit/>
+          </a:bodyPr>
+          <a:lstStyle/>
+          <a:p>
+            <a:r>
+              <a:rPr sz="1400" i="1">
+                <a:solidFill>
+                  <a:srgbClr val="5A5A5A"/>
+                </a:solidFill>
+              </a:rPr>
+              <a:t>Both sets scored at the fixed threshold of 0.70.</a:t>
+            </a:r>
+          </a:p>
+          <a:p>
+            <a:r>
+              <a:rPr sz="1400" i="1">
+                <a:solidFill>
+                  <a:srgbClr val="5A5A5A"/>
+                </a:solidFill>
+              </a:rPr>
+              <a:t>The second corpus is the honest test: a plagiarism checker meets text it was not trained on every single time somebody uses it.</a:t>
+            </a:r>
+          </a:p>
+        </p:txBody>
+      </p:sp>
+    </p:spTree>
+  </p:cSld>
+  <p:clrMapOvr>
+    <a:masterClrMapping/>
+  </p:clrMapOvr>
+</p:sld>
+</file>
+
+<file path=ppt/slides/slide12.xml><?xml version="1.0" encoding="utf-8"?>
+<p:sld xmlns:a="http://schemas.openxmlformats.org/drawingml/2006/main" xmlns:p="http://schemas.openxmlformats.org/presentationml/2006/main" xmlns:r="http://schemas.openxmlformats.org/officeDocument/2006/relationships">
+  <p:cSld>
+    <p:spTree>
+      <p:nvGrpSpPr>
+        <p:cNvPr id="1" name=""/>
+        <p:cNvGrpSpPr/>
+        <p:nvPr/>
+      </p:nvGrpSpPr>
+      <p:grpSpPr/>
+      <p:sp>
+        <p:nvSpPr>
+          <p:cNvPr id="2" name="Title 1"/>
+          <p:cNvSpPr>
+            <a:spLocks noGrp="1"/>
+          </p:cNvSpPr>
+          <p:nvPr>
+            <p:ph type="title"/>
+          </p:nvPr>
+        </p:nvSpPr>
+        <p:spPr/>
+        <p:txBody>
+          <a:bodyPr/>
+          <a:lstStyle/>
+          <a:p>
+            <a:r>
+              <a:t>What Those Numbers Say</a:t>
+            </a:r>
+          </a:p>
+        </p:txBody>
+      </p:sp>
+      <p:sp>
+        <p:nvSpPr>
+          <p:cNvPr id="3" name="Content Placeholder 2"/>
+          <p:cNvSpPr>
+            <a:spLocks noGrp="1"/>
+          </p:cNvSpPr>
+          <p:nvPr>
+            <p:ph idx="1"/>
+          </p:nvPr>
+        </p:nvSpPr>
+        <p:spPr/>
+        <p:txBody>
+          <a:bodyPr wrap="square"/>
+          <a:lstStyle/>
+          <a:p>
+            <a:pPr>
+              <a:spcAft>
+                <a:spcPts val="600"/>
+              </a:spcAft>
+            </a:pPr>
+            <a:r>
+              <a:rPr sz="1700" b="1">
+                <a:solidFill>
+                  <a:srgbClr val="1F3B73"/>
+                </a:solidFill>
+              </a:rPr>
+              <a:t>Fine tuning worked.</a:t>
+            </a:r>
+          </a:p>
+          <a:p>
+            <a:pPr lvl="1">
+              <a:spcAft>
+                <a:spcPts val="600"/>
+              </a:spcAft>
+            </a:pPr>
+            <a:r>
+              <a:rPr sz="1400" b="0"/>
+              <a:t>On the corpus it trained on, accuracy went from 0.7430 to 0.8260, a gain of 8.3 points.</a:t>
+            </a:r>
+          </a:p>
+          <a:p>
+            <a:pPr>
+              <a:spcAft>
+                <a:spcPts val="600"/>
+              </a:spcAft>
+            </a:pPr>
+            <a:r>
+              <a:rPr sz="1700" b="1">
+                <a:solidFill>
+                  <a:srgbClr val="1F3B73"/>
+                </a:solidFill>
+              </a:rPr>
+              <a:t>The word based baseline fails at the one job this project exists to do.</a:t>
+            </a:r>
+          </a:p>
+          <a:p>
+            <a:pPr lvl="1">
+              <a:spcAft>
+                <a:spcPts val="600"/>
+              </a:spcAft>
+            </a:pPr>
+            <a:r>
+              <a:rPr sz="1400" b="0"/>
+              <a:t>Its recall on paraphrased pairs is 0.2558. Roughly three reworded passages in every four walk straight past it.</a:t>
+            </a:r>
+          </a:p>
+          <a:p>
+            <a:pPr>
+              <a:spcAft>
+                <a:spcPts val="600"/>
+              </a:spcAft>
+            </a:pPr>
+            <a:r>
+              <a:rPr sz="1700" b="1">
+                <a:solidFill>
+                  <a:srgbClr val="1F3B73"/>
+                </a:solidFill>
+              </a:rPr>
+              <a:t>The classes separated further apart.</a:t>
+            </a:r>
+          </a:p>
+          <a:p>
+            <a:pPr lvl="1">
+              <a:spcAft>
+                <a:spcPts val="600"/>
+              </a:spcAft>
+            </a:pPr>
+            <a:r>
+              <a:rPr sz="1400" b="0"/>
+              <a:t>The distance between the average paraphrased score and the average unrelated score widened from 0.310 to 0.448. That is what gives a threshold room to sit in.</a:t>
+            </a:r>
+          </a:p>
+          <a:p>
+            <a:pPr>
+              <a:spcAft>
+                <a:spcPts val="600"/>
+              </a:spcAft>
+            </a:pPr>
+            <a:r>
+              <a:rPr sz="1700" b="1">
+                <a:solidFill>
+                  <a:srgbClr val="1F3B73"/>
+                </a:solidFill>
+              </a:rPr>
+              <a:t>We chose the cautious model.</a:t>
+            </a:r>
+          </a:p>
+          <a:p>
+            <a:pPr lvl="1">
+              <a:spcAft>
+                <a:spcPts val="600"/>
+              </a:spcAft>
+            </a:pPr>
+            <a:r>
+              <a:rPr sz="1400" b="0"/>
+              <a:t>The pretrained model produces 467 false positives, ours 166. A false positive is an accusation aimed at a student who did nothing wrong.</a:t>
+            </a:r>
+          </a:p>
+        </p:txBody>
+      </p:sp>
+    </p:spTree>
+  </p:cSld>
+  <p:clrMapOvr>
+    <a:masterClrMapping/>
+  </p:clrMapOvr>
+</p:sld>
+</file>
+
+<file path=ppt/slides/slide13.xml><?xml version="1.0" encoding="utf-8"?>
+<p:sld xmlns:a="http://schemas.openxmlformats.org/drawingml/2006/main" xmlns:p="http://schemas.openxmlformats.org/presentationml/2006/main" xmlns:r="http://schemas.openxmlformats.org/officeDocument/2006/relationships">
+  <p:cSld>
+    <p:spTree>
+      <p:nvGrpSpPr>
+        <p:cNvPr id="1" name=""/>
+        <p:cNvGrpSpPr/>
+        <p:nvPr/>
+      </p:nvGrpSpPr>
+      <p:grpSpPr/>
+      <p:sp>
+        <p:nvSpPr>
+          <p:cNvPr id="2" name="Title 1"/>
+          <p:cNvSpPr>
+            <a:spLocks noGrp="1"/>
+          </p:cNvSpPr>
+          <p:nvPr>
+            <p:ph type="title"/>
+          </p:nvPr>
+        </p:nvSpPr>
+        <p:spPr/>
+        <p:txBody>
+          <a:bodyPr/>
+          <a:lstStyle/>
+          <a:p>
+            <a:r>
+              <a:t>The Finding That Changed the Product</a:t>
+            </a:r>
+          </a:p>
+        </p:txBody>
+      </p:sp>
+      <p:sp>
+        <p:nvSpPr>
+          <p:cNvPr id="3" name="Content Placeholder 2"/>
+          <p:cNvSpPr>
+            <a:spLocks noGrp="1"/>
+          </p:cNvSpPr>
+          <p:nvPr>
+            <p:ph idx="1"/>
+          </p:nvPr>
+        </p:nvSpPr>
+        <p:spPr/>
+        <p:txBody>
+          <a:bodyPr wrap="square"/>
+          <a:lstStyle/>
+          <a:p>
+            <a:pPr>
+              <a:spcAft>
+                <a:spcPts val="600"/>
+              </a:spcAft>
+            </a:pPr>
+            <a:r>
+              <a:rPr sz="1700" b="0"/>
+              <a:t>Fine tuning does not simply lift every number on the page. It moves the scale the model scores on.</a:t>
+            </a:r>
+          </a:p>
+          <a:p>
+            <a:pPr>
+              <a:spcAft>
+                <a:spcPts val="600"/>
+              </a:spcAft>
+            </a:pPr>
+            <a:r>
+              <a:rPr sz="1700" b="0"/>
+              <a:t>On the corpus we trained on, the best threshold for our model is 0.70, the value already in the code.</a:t>
+            </a:r>
+          </a:p>
+          <a:p>
+            <a:pPr>
+              <a:spcAft>
+                <a:spcPts val="600"/>
+              </a:spcAft>
+            </a:pPr>
+            <a:r>
+              <a:rPr sz="1700" b="0"/>
+              <a:t>On the corpus it had never seen, the same model wants 0.45. Held at 0.70 it scores 0.6691 there, against 0.7328 once the threshold is tuned.</a:t>
+            </a:r>
+          </a:p>
+          <a:p>
+            <a:pPr>
+              <a:spcAft>
+                <a:spcPts val="600"/>
+              </a:spcAft>
+            </a:pPr>
+            <a:r>
+              <a:rPr sz="1700" b="0"/>
+              <a:t>So a threshold fixed against one corpus is quietly wrong for another. We only saw it because we evaluated on a corpus the model had never met.</a:t>
+            </a:r>
+          </a:p>
+          <a:p>
+            <a:pPr>
+              <a:spcAft>
+                <a:spcPts val="600"/>
+              </a:spcAft>
+            </a:pPr>
+            <a:r>
+              <a:rPr sz="1700" b="1">
+                <a:solidFill>
+                  <a:srgbClr val="1F3B73"/>
+                </a:solidFill>
+              </a:rPr>
+              <a:t>The threshold left the source code and became a slider in the interface, and the value actually used is printed beside every result.</a:t>
+            </a:r>
+          </a:p>
+        </p:txBody>
+      </p:sp>
+    </p:spTree>
+  </p:cSld>
+  <p:clrMapOvr>
+    <a:masterClrMapping/>
+  </p:clrMapOvr>
+</p:sld>
+</file>
+
+<file path=ppt/slides/slide14.xml><?xml version="1.0" encoding="utf-8"?>
+<p:sld xmlns:a="http://schemas.openxmlformats.org/drawingml/2006/main" xmlns:p="http://schemas.openxmlformats.org/presentationml/2006/main" xmlns:r="http://schemas.openxmlformats.org/officeDocument/2006/relationships">
+  <p:cSld>
+    <p:spTree>
+      <p:nvGrpSpPr>
+        <p:cNvPr id="1" name=""/>
+        <p:cNvGrpSpPr/>
+        <p:nvPr/>
+      </p:nvGrpSpPr>
+      <p:grpSpPr/>
+      <p:sp>
+        <p:nvSpPr>
+          <p:cNvPr id="2" name="Title 1"/>
+          <p:cNvSpPr>
+            <a:spLocks noGrp="1"/>
+          </p:cNvSpPr>
+          <p:nvPr>
+            <p:ph type="title"/>
+          </p:nvPr>
+        </p:nvSpPr>
+        <p:spPr/>
+        <p:txBody>
+          <a:bodyPr/>
+          <a:lstStyle/>
+          <a:p>
+            <a:r>
+              <a:t>Speed: 5.1 Times Faster</a:t>
+            </a:r>
+          </a:p>
+        </p:txBody>
+      </p:sp>
+      <p:sp>
+        <p:nvSpPr>
+          <p:cNvPr id="3" name="TextBox 2"/>
+          <p:cNvSpPr txBox="1"/>
+          <p:nvPr/>
         </p:nvSpPr>
         <p:spPr>
           <a:xfrm>
-            <a:off x="1474967" y="1198658"/>
-            <a:ext cx="6400800" cy="5469035"/>
+            <a:off x="457200" y="1463040"/>
+            <a:ext cx="4206240" cy="4114800"/>
           </a:xfrm>
+          <a:prstGeom prst="rect">
+            <a:avLst/>
+          </a:prstGeom>
+          <a:noFill/>
         </p:spPr>
         <p:txBody>
-          <a:bodyPr>
-            <a:normAutofit fontScale="92500" lnSpcReduction="10000"/>
+          <a:bodyPr wrap="square">
+            <a:spAutoFit/>
           </a:bodyPr>
           <a:lstStyle/>
           <a:p>
-            <a:r>
-              <a:rPr dirty="0">
+            <a:pPr>
+              <a:spcAft>
+                <a:spcPts val="800"/>
+              </a:spcAft>
+            </a:pPr>
+            <a:r>
+              <a:rPr sz="1500" b="0"/>
+              <a:t>10 documents, about 2628 words each, 1335 sentences, all 45 pairs highlighted, on the processor.</a:t>
+            </a:r>
+          </a:p>
+          <a:p>
+            <a:pPr>
+              <a:spcAft>
+                <a:spcPts val="800"/>
+              </a:spcAft>
+            </a:pPr>
+            <a:r>
+              <a:rPr sz="1500" b="1"/>
+              <a:t>Before: 27.1 seconds</a:t>
+            </a:r>
+          </a:p>
+          <a:p>
+            <a:pPr lvl="1">
+              <a:spcAft>
+                <a:spcPts val="800"/>
+              </a:spcAft>
+            </a:pPr>
+            <a:r>
+              <a:rPr sz="1300" b="0"/>
+              <a:t>The whole document in one call, and its sentences encoded again for every pair it appeared in.</a:t>
+            </a:r>
+          </a:p>
+          <a:p>
+            <a:pPr>
+              <a:spcAft>
+                <a:spcPts val="800"/>
+              </a:spcAft>
+            </a:pPr>
+            <a:r>
+              <a:rPr sz="1500" b="1"/>
+              <a:t>After: 5.3 seconds</a:t>
+            </a:r>
+          </a:p>
+          <a:p>
+            <a:pPr lvl="1">
+              <a:spcAft>
+                <a:spcPts val="800"/>
+              </a:spcAft>
+            </a:pPr>
+            <a:r>
+              <a:rPr sz="1300" b="0"/>
+              <a:t>Chunks of five sentences, pushed through in batches, every encoded sentence cached.</a:t>
+            </a:r>
+          </a:p>
+          <a:p>
+            <a:pPr>
+              <a:spcAft>
+                <a:spcPts val="800"/>
+              </a:spcAft>
+            </a:pPr>
+            <a:r>
+              <a:rPr sz="1500" b="0"/>
+              <a:t>It also uncovered a defect. The model truncates anything longer than its input window, so the tail of a long document was never being compared and nothing in the output said so.</a:t>
+            </a:r>
+          </a:p>
+        </p:txBody>
+      </p:sp>
+      <p:pic>
+        <p:nvPicPr>
+          <p:cNvPr id="4" name="Picture 3" descr="fig8_timing.png"/>
+          <p:cNvPicPr>
+            <a:picLocks noChangeAspect="1"/>
+          </p:cNvPicPr>
+          <p:nvPr/>
+        </p:nvPicPr>
+        <p:blipFill>
+          <a:blip r:embed="rId2"/>
+          <a:stretch>
+            <a:fillRect/>
+          </a:stretch>
+        </p:blipFill>
+        <p:spPr>
+          <a:xfrm>
+            <a:off x="4754880" y="2286000"/>
+            <a:ext cx="4114800" cy="2296633"/>
+          </a:xfrm>
+          <a:prstGeom prst="rect">
+            <a:avLst/>
+          </a:prstGeom>
+        </p:spPr>
+      </p:pic>
+    </p:spTree>
+  </p:cSld>
+  <p:clrMapOvr>
+    <a:masterClrMapping/>
+  </p:clrMapOvr>
+</p:sld>
+</file>
+
+<file path=ppt/slides/slide15.xml><?xml version="1.0" encoding="utf-8"?>
+<p:sld xmlns:a="http://schemas.openxmlformats.org/drawingml/2006/main" xmlns:p="http://schemas.openxmlformats.org/presentationml/2006/main" xmlns:r="http://schemas.openxmlformats.org/officeDocument/2006/relationships">
+  <p:cSld>
+    <p:spTree>
+      <p:nvGrpSpPr>
+        <p:cNvPr id="1" name=""/>
+        <p:cNvGrpSpPr/>
+        <p:nvPr/>
+      </p:nvGrpSpPr>
+      <p:grpSpPr/>
+      <p:sp>
+        <p:nvSpPr>
+          <p:cNvPr id="2" name="Title 1"/>
+          <p:cNvSpPr>
+            <a:spLocks noGrp="1"/>
+          </p:cNvSpPr>
+          <p:nvPr>
+            <p:ph type="title"/>
+          </p:nvPr>
+        </p:nvSpPr>
+        <p:spPr/>
+        <p:txBody>
+          <a:bodyPr/>
+          <a:lstStyle/>
+          <a:p>
+            <a:r>
+              <a:t>Testing</a:t>
+            </a:r>
+          </a:p>
+        </p:txBody>
+      </p:sp>
+      <p:sp>
+        <p:nvSpPr>
+          <p:cNvPr id="3" name="Content Placeholder 2"/>
+          <p:cNvSpPr>
+            <a:spLocks noGrp="1"/>
+          </p:cNvSpPr>
+          <p:nvPr>
+            <p:ph idx="1"/>
+          </p:nvPr>
+        </p:nvSpPr>
+        <p:spPr/>
+        <p:txBody>
+          <a:bodyPr wrap="square"/>
+          <a:lstStyle/>
+          <a:p>
+            <a:pPr>
+              <a:spcAft>
+                <a:spcPts val="600"/>
+              </a:spcAft>
+            </a:pPr>
+            <a:r>
+              <a:rPr sz="1700" b="1">
                 <a:solidFill>
-                  <a:schemeClr val="tx1"/>
+                  <a:srgbClr val="1F3B73"/>
                 </a:solidFill>
               </a:rPr>
-              <a:t>Minor II Project Progress Presentation</a:t>
-            </a:r>
-          </a:p>
-          <a:p>
-            <a:endParaRPr dirty="0">
-              <a:solidFill>
-                <a:schemeClr val="tx1"/>
-              </a:solidFill>
-            </a:endParaRPr>
-          </a:p>
-          <a:p>
-            <a:r>
-              <a:rPr dirty="0">
+              <a:t>Twenty four unit tests, all passing.</a:t>
+            </a:r>
+          </a:p>
+          <a:p>
+            <a:pPr lvl="1">
+              <a:spcAft>
+                <a:spcPts val="600"/>
+              </a:spcAft>
+            </a:pPr>
+            <a:r>
+              <a:rPr sz="1400" b="0"/>
+              <a:t>preprocess 9, text_extraction 7, similarity 8.</a:t>
+            </a:r>
+          </a:p>
+          <a:p>
+            <a:pPr lvl="1">
+              <a:spcAft>
+                <a:spcPts val="600"/>
+              </a:spcAft>
+            </a:pPr>
+            <a:r>
+              <a:rPr sz="1400" b="0"/>
+              <a:t>None of them start Django and none of them load the trained model, so the suite finishes in well under a second and we ran it after every change.</a:t>
+            </a:r>
+          </a:p>
+          <a:p>
+            <a:pPr>
+              <a:spcAft>
+                <a:spcPts val="600"/>
+              </a:spcAft>
+            </a:pPr>
+            <a:r>
+              <a:rPr sz="1700" b="1">
                 <a:solidFill>
-                  <a:schemeClr val="tx1"/>
+                  <a:srgbClr val="1F3B73"/>
                 </a:solidFill>
               </a:rPr>
-              <a:t>Gandaki College of Engineering and Science</a:t>
-            </a:r>
-          </a:p>
-          <a:p>
-            <a:endParaRPr dirty="0">
-              <a:solidFill>
-                <a:schemeClr val="tx1"/>
-              </a:solidFill>
-            </a:endParaRPr>
-          </a:p>
-          <a:p>
-            <a:r>
-              <a:rPr dirty="0">
+              <a:t>A functional walk through of the whole system.</a:t>
+            </a:r>
+          </a:p>
+          <a:p>
+            <a:pPr lvl="1">
+              <a:spcAft>
+                <a:spcPts val="600"/>
+              </a:spcAft>
+            </a:pPr>
+            <a:r>
+              <a:rPr sz="1400" b="0"/>
+              <a:t>Every supported format, and every failure case: no file, one file, unsupported type, empty file, corrupt DOCX, unreadable scan, a web page that refuses to answer.</a:t>
+            </a:r>
+          </a:p>
+          <a:p>
+            <a:pPr lvl="1">
+              <a:spcAft>
+                <a:spcPts val="600"/>
+              </a:spcAft>
+            </a:pPr>
+            <a:r>
+              <a:rPr sz="1400" b="0"/>
+              <a:t>A document compared with itself returns exactly 1.00, and an unrelated pair sits near zero.</a:t>
+            </a:r>
+          </a:p>
+          <a:p>
+            <a:pPr>
+              <a:spcAft>
+                <a:spcPts val="600"/>
+              </a:spcAft>
+            </a:pPr>
+            <a:r>
+              <a:rPr sz="1700" b="1">
                 <a:solidFill>
-                  <a:schemeClr val="tx1"/>
+                  <a:srgbClr val="1F3B73"/>
                 </a:solidFill>
               </a:rPr>
-              <a:t>Presented by:</a:t>
-            </a:r>
-          </a:p>
-          <a:p>
-            <a:r>
-              <a:rPr dirty="0">
+              <a:t>User testing.</a:t>
+            </a:r>
+          </a:p>
+          <a:p>
+            <a:pPr lvl="1">
+              <a:spcAft>
+                <a:spcPts val="600"/>
+              </a:spcAft>
+            </a:pPr>
+            <a:r>
+              <a:rPr sz="1400" b="0"/>
+              <a:t>Classmates and teachers used the finished application on their own work, which is where the most useful criticism came from.</a:t>
+            </a:r>
+          </a:p>
+        </p:txBody>
+      </p:sp>
+    </p:spTree>
+  </p:cSld>
+  <p:clrMapOvr>
+    <a:masterClrMapping/>
+  </p:clrMapOvr>
+</p:sld>
+</file>
+
+<file path=ppt/slides/slide16.xml><?xml version="1.0" encoding="utf-8"?>
+<p:sld xmlns:a="http://schemas.openxmlformats.org/drawingml/2006/main" xmlns:p="http://schemas.openxmlformats.org/presentationml/2006/main" xmlns:r="http://schemas.openxmlformats.org/officeDocument/2006/relationships">
+  <p:cSld>
+    <p:spTree>
+      <p:nvGrpSpPr>
+        <p:cNvPr id="1" name=""/>
+        <p:cNvGrpSpPr/>
+        <p:nvPr/>
+      </p:nvGrpSpPr>
+      <p:grpSpPr/>
+      <p:sp>
+        <p:nvSpPr>
+          <p:cNvPr id="2" name="Title 1"/>
+          <p:cNvSpPr>
+            <a:spLocks noGrp="1"/>
+          </p:cNvSpPr>
+          <p:nvPr>
+            <p:ph type="title"/>
+          </p:nvPr>
+        </p:nvSpPr>
+        <p:spPr/>
+        <p:txBody>
+          <a:bodyPr/>
+          <a:lstStyle/>
+          <a:p>
+            <a:r>
+              <a:t>The Finished Application</a:t>
+            </a:r>
+          </a:p>
+        </p:txBody>
+      </p:sp>
+      <p:pic>
+        <p:nvPicPr>
+          <p:cNvPr id="3" name="Picture 2" descr="annex2_matrix.png"/>
+          <p:cNvPicPr>
+            <a:picLocks noChangeAspect="1"/>
+          </p:cNvPicPr>
+          <p:nvPr/>
+        </p:nvPicPr>
+        <p:blipFill>
+          <a:blip r:embed="rId2"/>
+          <a:stretch>
+            <a:fillRect/>
+          </a:stretch>
+        </p:blipFill>
+        <p:spPr>
+          <a:xfrm>
+            <a:off x="274320" y="1600200"/>
+            <a:ext cx="4297680" cy="2958013"/>
+          </a:xfrm>
+          <a:prstGeom prst="rect">
+            <a:avLst/>
+          </a:prstGeom>
+        </p:spPr>
+      </p:pic>
+      <p:pic>
+        <p:nvPicPr>
+          <p:cNvPr id="4" name="Picture 3" descr="annex3_highlight.png"/>
+          <p:cNvPicPr>
+            <a:picLocks noChangeAspect="1"/>
+          </p:cNvPicPr>
+          <p:nvPr/>
+        </p:nvPicPr>
+        <p:blipFill>
+          <a:blip r:embed="rId3"/>
+          <a:stretch>
+            <a:fillRect/>
+          </a:stretch>
+        </p:blipFill>
+        <p:spPr>
+          <a:xfrm>
+            <a:off x="4572000" y="2057400"/>
+            <a:ext cx="4297680" cy="2293215"/>
+          </a:xfrm>
+          <a:prstGeom prst="rect">
+            <a:avLst/>
+          </a:prstGeom>
+        </p:spPr>
+      </p:pic>
+      <p:sp>
+        <p:nvSpPr>
+          <p:cNvPr id="5" name="TextBox 4"/>
+          <p:cNvSpPr txBox="1"/>
+          <p:nvPr/>
+        </p:nvSpPr>
+        <p:spPr>
+          <a:xfrm>
+            <a:off x="365760" y="5212080"/>
+            <a:ext cx="8412480" cy="731520"/>
+          </a:xfrm>
+          <a:prstGeom prst="rect">
+            <a:avLst/>
+          </a:prstGeom>
+          <a:noFill/>
+        </p:spPr>
+        <p:txBody>
+          <a:bodyPr wrap="none">
+            <a:spAutoFit/>
+          </a:bodyPr>
+          <a:lstStyle/>
+          <a:p>
+            <a:pPr algn="ctr"/>
+            <a:r>
+              <a:rPr sz="1400" i="1">
                 <a:solidFill>
-                  <a:schemeClr val="tx1"/>
+                  <a:srgbClr val="5A5A5A"/>
                 </a:solidFill>
               </a:rPr>
-              <a:t>Neon Neupane</a:t>
-            </a:r>
-          </a:p>
-          <a:p>
-            <a:r>
-              <a:rPr dirty="0">
+              <a:t>The similarity matrix over the batch, and the copied sentences marked inside the document.</a:t>
+            </a:r>
+          </a:p>
+        </p:txBody>
+      </p:sp>
+    </p:spTree>
+  </p:cSld>
+  <p:clrMapOvr>
+    <a:masterClrMapping/>
+  </p:clrMapOvr>
+</p:sld>
+</file>
+
+<file path=ppt/slides/slide17.xml><?xml version="1.0" encoding="utf-8"?>
+<p:sld xmlns:a="http://schemas.openxmlformats.org/drawingml/2006/main" xmlns:p="http://schemas.openxmlformats.org/presentationml/2006/main" xmlns:r="http://schemas.openxmlformats.org/officeDocument/2006/relationships">
+  <p:cSld>
+    <p:spTree>
+      <p:nvGrpSpPr>
+        <p:cNvPr id="1" name=""/>
+        <p:cNvGrpSpPr/>
+        <p:nvPr/>
+      </p:nvGrpSpPr>
+      <p:grpSpPr/>
+      <p:sp>
+        <p:nvSpPr>
+          <p:cNvPr id="2" name="Title 1"/>
+          <p:cNvSpPr>
+            <a:spLocks noGrp="1"/>
+          </p:cNvSpPr>
+          <p:nvPr>
+            <p:ph type="title"/>
+          </p:nvPr>
+        </p:nvSpPr>
+        <p:spPr/>
+        <p:txBody>
+          <a:bodyPr/>
+          <a:lstStyle/>
+          <a:p>
+            <a:r>
+              <a:t>Limitations</a:t>
+            </a:r>
+          </a:p>
+        </p:txBody>
+      </p:sp>
+      <p:sp>
+        <p:nvSpPr>
+          <p:cNvPr id="3" name="Content Placeholder 2"/>
+          <p:cNvSpPr>
+            <a:spLocks noGrp="1"/>
+          </p:cNvSpPr>
+          <p:nvPr>
+            <p:ph idx="1"/>
+          </p:nvPr>
+        </p:nvSpPr>
+        <p:spPr/>
+        <p:txBody>
+          <a:bodyPr wrap="square"/>
+          <a:lstStyle/>
+          <a:p>
+            <a:pPr>
+              <a:spcAft>
+                <a:spcPts val="600"/>
+              </a:spcAft>
+            </a:pPr>
+            <a:r>
+              <a:rPr sz="1600" b="0"/>
+              <a:t>Nepali accuracy sits below English accuracy. We adapted the text handling for Devanagari but not the model, which learned from English pairs only.</a:t>
+            </a:r>
+          </a:p>
+          <a:p>
+            <a:pPr>
+              <a:spcAft>
+                <a:spcPts val="600"/>
+              </a:spcAft>
+            </a:pPr>
+            <a:r>
+              <a:rPr sz="1600" b="0"/>
+              <a:t>The best threshold for one kind of text is not the best for another. We put the control in the interface, but the user still has to understand what they are moving.</a:t>
+            </a:r>
+          </a:p>
+          <a:p>
+            <a:pPr>
+              <a:spcAft>
+                <a:spcPts val="600"/>
+              </a:spcAft>
+            </a:pPr>
+            <a:r>
+              <a:rPr sz="1600" b="0"/>
+              <a:t>The web check only sees what it can reach at that moment, so it is never exhaustive.</a:t>
+            </a:r>
+          </a:p>
+          <a:p>
+            <a:pPr>
+              <a:spcAft>
+                <a:spcPts val="600"/>
+              </a:spcAft>
+            </a:pPr>
+            <a:r>
+              <a:rPr sz="1600" b="0"/>
+              <a:t>A poor scan gives poor text out of the recognition step, and no model quality downstream can repair that.</a:t>
+            </a:r>
+          </a:p>
+          <a:p>
+            <a:pPr>
+              <a:spcAft>
+                <a:spcPts val="600"/>
+              </a:spcAft>
+            </a:pPr>
+            <a:r>
+              <a:rPr sz="1600" b="0"/>
+              <a:t>There is no archive of past submissions, so a paragraph lifted from a report handed in three years ago goes straight through.</a:t>
+            </a:r>
+          </a:p>
+          <a:p>
+            <a:pPr>
+              <a:spcAft>
+                <a:spcPts val="600"/>
+              </a:spcAft>
+            </a:pPr>
+            <a:r>
+              <a:rPr sz="1600" b="0"/>
+              <a:t>Source code, mathematical notation and figures are not handled at all.</a:t>
+            </a:r>
+          </a:p>
+        </p:txBody>
+      </p:sp>
+    </p:spTree>
+  </p:cSld>
+  <p:clrMapOvr>
+    <a:masterClrMapping/>
+  </p:clrMapOvr>
+</p:sld>
+</file>
+
+<file path=ppt/slides/slide18.xml><?xml version="1.0" encoding="utf-8"?>
+<p:sld xmlns:a="http://schemas.openxmlformats.org/drawingml/2006/main" xmlns:p="http://schemas.openxmlformats.org/presentationml/2006/main" xmlns:r="http://schemas.openxmlformats.org/officeDocument/2006/relationships">
+  <p:cSld>
+    <p:spTree>
+      <p:nvGrpSpPr>
+        <p:cNvPr id="1" name=""/>
+        <p:cNvGrpSpPr/>
+        <p:nvPr/>
+      </p:nvGrpSpPr>
+      <p:grpSpPr/>
+      <p:sp>
+        <p:nvSpPr>
+          <p:cNvPr id="2" name="Title 1"/>
+          <p:cNvSpPr>
+            <a:spLocks noGrp="1"/>
+          </p:cNvSpPr>
+          <p:nvPr>
+            <p:ph type="title"/>
+          </p:nvPr>
+        </p:nvSpPr>
+        <p:spPr/>
+        <p:txBody>
+          <a:bodyPr/>
+          <a:lstStyle/>
+          <a:p>
+            <a:r>
+              <a:t>Conclusion and Future Work</a:t>
+            </a:r>
+          </a:p>
+        </p:txBody>
+      </p:sp>
+      <p:sp>
+        <p:nvSpPr>
+          <p:cNvPr id="3" name="Content Placeholder 2"/>
+          <p:cNvSpPr>
+            <a:spLocks noGrp="1"/>
+          </p:cNvSpPr>
+          <p:nvPr>
+            <p:ph idx="1"/>
+          </p:nvPr>
+        </p:nvSpPr>
+        <p:spPr/>
+        <p:txBody>
+          <a:bodyPr wrap="square"/>
+          <a:lstStyle/>
+          <a:p>
+            <a:pPr>
+              <a:spcAft>
+                <a:spcPts val="600"/>
+              </a:spcAft>
+            </a:pPr>
+            <a:r>
+              <a:rPr sz="1700" b="0"/>
+              <a:t>We set out to build a free plagiarism detector that compares meaning instead of words. That is done, and it has been measured rather than asserted.</a:t>
+            </a:r>
+          </a:p>
+          <a:p>
+            <a:pPr>
+              <a:spcAft>
+                <a:spcPts val="600"/>
+              </a:spcAft>
+            </a:pPr>
+            <a:r>
+              <a:rPr sz="1700" b="1">
                 <a:solidFill>
-                  <a:schemeClr val="tx1"/>
+                  <a:srgbClr val="1F3B73"/>
                 </a:solidFill>
               </a:rPr>
-              <a:t>Bishal Acharya</a:t>
-            </a:r>
-          </a:p>
-          <a:p>
-            <a:r>
-              <a:rPr dirty="0">
-                <a:solidFill>
-                  <a:schemeClr val="tx1"/>
-                </a:solidFill>
-              </a:rPr>
-              <a:t>Nabin Giri</a:t>
-            </a:r>
-          </a:p>
-          <a:p>
-            <a:endParaRPr dirty="0">
-              <a:solidFill>
-                <a:schemeClr val="tx1"/>
-              </a:solidFill>
-            </a:endParaRPr>
-          </a:p>
-          <a:p>
-            <a:r>
-              <a:rPr dirty="0">
-                <a:solidFill>
-                  <a:schemeClr val="tx1"/>
-                </a:solidFill>
-              </a:rPr>
-              <a:t>Date: </a:t>
-            </a:r>
-            <a:r>
-              <a:rPr dirty="0" err="1">
-                <a:solidFill>
-                  <a:schemeClr val="tx1"/>
-                </a:solidFill>
-              </a:rPr>
-              <a:t>Shrawan</a:t>
-            </a:r>
-            <a:r>
-              <a:rPr>
-                <a:solidFill>
-                  <a:schemeClr val="tx1"/>
-                </a:solidFill>
-              </a:rPr>
-              <a:t> 12, </a:t>
-            </a:r>
-            <a:r>
-              <a:rPr dirty="0">
-                <a:solidFill>
-                  <a:schemeClr val="tx1"/>
-                </a:solidFill>
-              </a:rPr>
-              <a:t>2083</a:t>
+              <a:t>Future work</a:t>
+            </a:r>
+          </a:p>
+          <a:p>
+            <a:pPr lvl="1">
+              <a:spcAft>
+                <a:spcPts val="600"/>
+              </a:spcAft>
+            </a:pPr>
+            <a:r>
+              <a:rPr sz="1500" b="0"/>
+              <a:t>Train on a corpus of real student work, so the model sees the copying that actually happens in assignments.</a:t>
+            </a:r>
+          </a:p>
+          <a:p>
+            <a:pPr lvl="1">
+              <a:spcAft>
+                <a:spcPts val="600"/>
+              </a:spcAft>
+            </a:pPr>
+            <a:r>
+              <a:rPr sz="1500" b="0"/>
+              <a:t>Fine tune a multilingual model on Nepali paraphrase pairs, so Devanagari accuracy matches English.</a:t>
+            </a:r>
+          </a:p>
+          <a:p>
+            <a:pPr lvl="1">
+              <a:spcAft>
+                <a:spcPts val="600"/>
+              </a:spcAft>
+            </a:pPr>
+            <a:r>
+              <a:rPr sz="1500" b="0"/>
+              <a:t>Add an archive of past submissions for a department.</a:t>
+            </a:r>
+          </a:p>
+          <a:p>
+            <a:pPr lvl="1">
+              <a:spcAft>
+                <a:spcPts val="600"/>
+              </a:spcAft>
+            </a:pPr>
+            <a:r>
+              <a:rPr sz="1500" b="0"/>
+              <a:t>Add support for source code, where plagiarism is detected by comparing structure rather than text.</a:t>
+            </a:r>
+          </a:p>
+          <a:p>
+            <a:pPr lvl="1">
+              <a:spcAft>
+                <a:spcPts val="600"/>
+              </a:spcAft>
+            </a:pPr>
+            <a:r>
+              <a:rPr sz="1500" b="0"/>
+              <a:t>Add optional accounts for teachers who want to keep reports, with the anonymous mode staying the default.</a:t>
+            </a:r>
+          </a:p>
+        </p:txBody>
+      </p:sp>
+    </p:spTree>
+  </p:cSld>
+  <p:clrMapOvr>
+    <a:masterClrMapping/>
+  </p:clrMapOvr>
+</p:sld>
+</file>
+
+<file path=ppt/slides/slide19.xml><?xml version="1.0" encoding="utf-8"?>
+<p:sld xmlns:a="http://schemas.openxmlformats.org/drawingml/2006/main" xmlns:p="http://schemas.openxmlformats.org/presentationml/2006/main" xmlns:r="http://schemas.openxmlformats.org/officeDocument/2006/relationships">
+  <p:cSld>
+    <p:spTree>
+      <p:nvGrpSpPr>
+        <p:cNvPr id="1" name=""/>
+        <p:cNvGrpSpPr/>
+        <p:nvPr/>
+      </p:nvGrpSpPr>
+      <p:grpSpPr/>
+      <p:sp>
+        <p:nvSpPr>
+          <p:cNvPr id="2" name="Title 1"/>
+          <p:cNvSpPr>
+            <a:spLocks noGrp="1"/>
+          </p:cNvSpPr>
+          <p:nvPr>
+            <p:ph type="ctrTitle"/>
+          </p:nvPr>
+        </p:nvSpPr>
+        <p:spPr/>
+        <p:txBody>
+          <a:bodyPr/>
+          <a:lstStyle/>
+          <a:p>
+            <a:r>
+              <a:t>Thank You</a:t>
+            </a:r>
+          </a:p>
+        </p:txBody>
+      </p:sp>
+      <p:sp>
+        <p:nvSpPr>
+          <p:cNvPr id="3" name="Subtitle 2"/>
+          <p:cNvSpPr>
+            <a:spLocks noGrp="1"/>
+          </p:cNvSpPr>
+          <p:nvPr>
+            <p:ph type="subTitle" idx="1"/>
+          </p:nvPr>
+        </p:nvSpPr>
+        <p:spPr/>
+        <p:txBody>
+          <a:bodyPr/>
+          <a:lstStyle/>
+          <a:p>
+            <a:r>
+              <a:t>Questions and Feedback</a:t>
             </a:r>
           </a:p>
         </p:txBody>
@@ -3269,7 +4982,7 @@
 </file>
 
 <file path=ppt/slides/slide2.xml><?xml version="1.0" encoding="utf-8"?>
-<p:sld xmlns:a="http://schemas.openxmlformats.org/drawingml/2006/main" xmlns:r="http://schemas.openxmlformats.org/officeDocument/2006/relationships" xmlns:p="http://schemas.openxmlformats.org/presentationml/2006/main">
+<p:sld xmlns:a="http://schemas.openxmlformats.org/drawingml/2006/main" xmlns:p="http://schemas.openxmlformats.org/presentationml/2006/main" xmlns:r="http://schemas.openxmlformats.org/officeDocument/2006/relationships">
   <p:cSld>
     <p:spTree>
       <p:nvGrpSpPr>
@@ -3277,14 +4990,7 @@
         <p:cNvGrpSpPr/>
         <p:nvPr/>
       </p:nvGrpSpPr>
-      <p:grpSpPr>
-        <a:xfrm>
-          <a:off x="0" y="0"/>
-          <a:ext cx="0" cy="0"/>
-          <a:chOff x="0" y="0"/>
-          <a:chExt cx="0" cy="0"/>
-        </a:xfrm>
-      </p:grpSpPr>
+      <p:grpSpPr/>
       <p:sp>
         <p:nvSpPr>
           <p:cNvPr id="2" name="Title 1"/>
@@ -3301,7 +5007,7 @@
           <a:lstStyle/>
           <a:p>
             <a:r>
-              <a:t>Project Overview</a:t>
+              <a:t>The Problem</a:t>
             </a:r>
           </a:p>
         </p:txBody>
@@ -3318,40 +5024,94 @@
         </p:nvSpPr>
         <p:spPr/>
         <p:txBody>
-          <a:bodyPr/>
-          <a:lstStyle/>
-          <a:p>
-            <a:r>
-              <a:t>What is it? A free, web-based plagiarism detector.</a:t>
-            </a:r>
-          </a:p>
-          <a:p>
-            <a:r>
-              <a:t>Key Features:</a:t>
-            </a:r>
-          </a:p>
-          <a:p>
-            <a:pPr lvl="1"/>
-            <a:r>
-              <a:t>Upload multiple files (PDF, Word, Text, Images).</a:t>
-            </a:r>
-          </a:p>
-          <a:p>
-            <a:pPr lvl="1"/>
-            <a:r>
-              <a:t>Automatically extracts text (even from images using OCR).</a:t>
-            </a:r>
-          </a:p>
-          <a:p>
-            <a:pPr lvl="1"/>
-            <a:r>
-              <a:t>Checks if documents in a batch copied from each other.</a:t>
-            </a:r>
-          </a:p>
-          <a:p>
-            <a:pPr lvl="1"/>
-            <a:r>
-              <a:t>Checks documents against pages on the internet (Web checking).</a:t>
+          <a:bodyPr wrap="square"/>
+          <a:lstStyle/>
+          <a:p>
+            <a:pPr>
+              <a:spcAft>
+                <a:spcPts val="600"/>
+              </a:spcAft>
+            </a:pPr>
+            <a:r>
+              <a:rPr sz="2000" b="0"/>
+              <a:t>Free checkers compare words, not meaning.</a:t>
+            </a:r>
+          </a:p>
+          <a:p>
+            <a:pPr lvl="1">
+              <a:spcAft>
+                <a:spcPts val="600"/>
+              </a:spcAft>
+            </a:pPr>
+            <a:r>
+              <a:rPr sz="1600" b="0"/>
+              <a:t>Reword four words in a sentence and the reported similarity collapses.</a:t>
+            </a:r>
+          </a:p>
+          <a:p>
+            <a:pPr>
+              <a:spcAft>
+                <a:spcPts val="600"/>
+              </a:spcAft>
+            </a:pPr>
+            <a:r>
+              <a:rPr sz="2000" b="0"/>
+              <a:t>The tools that do it properly are out of reach.</a:t>
+            </a:r>
+          </a:p>
+          <a:p>
+            <a:pPr lvl="1">
+              <a:spcAft>
+                <a:spcPts val="600"/>
+              </a:spcAft>
+            </a:pPr>
+            <a:r>
+              <a:rPr sz="1600" b="0"/>
+              <a:t>Turnitin sells to institutions; Quetext and Copyleaks give a small free quota, then ask for a card.</a:t>
+            </a:r>
+          </a:p>
+          <a:p>
+            <a:pPr>
+              <a:spcAft>
+                <a:spcPts val="600"/>
+              </a:spcAft>
+            </a:pPr>
+            <a:r>
+              <a:rPr sz="2000" b="0"/>
+              <a:t>Three problems nobody solves for a Nepali college:</a:t>
+            </a:r>
+          </a:p>
+          <a:p>
+            <a:pPr lvl="1">
+              <a:spcAft>
+                <a:spcPts val="600"/>
+              </a:spcAft>
+            </a:pPr>
+            <a:r>
+              <a:rPr sz="1600" b="0"/>
+              <a:t>A large share of what is submitted is scanned, not typed.</a:t>
+            </a:r>
+          </a:p>
+          <a:p>
+            <a:pPr lvl="1">
+              <a:spcAft>
+                <a:spcPts val="600"/>
+              </a:spcAft>
+            </a:pPr>
+            <a:r>
+              <a:rPr sz="1600" b="0"/>
+              <a:t>Devanagari is thrown away before the comparison even starts.</a:t>
+            </a:r>
+          </a:p>
+          <a:p>
+            <a:pPr lvl="1">
+              <a:spcAft>
+                <a:spcPts val="600"/>
+              </a:spcAft>
+            </a:pPr>
+            <a:r>
+              <a:rPr sz="1600" b="0"/>
+              <a:t>The free services keep a copy of every file you hand them.</a:t>
             </a:r>
           </a:p>
         </p:txBody>
@@ -3365,7 +5125,7 @@
 </file>
 
 <file path=ppt/slides/slide3.xml><?xml version="1.0" encoding="utf-8"?>
-<p:sld xmlns:a="http://schemas.openxmlformats.org/drawingml/2006/main" xmlns:r="http://schemas.openxmlformats.org/officeDocument/2006/relationships" xmlns:p="http://schemas.openxmlformats.org/presentationml/2006/main">
+<p:sld xmlns:a="http://schemas.openxmlformats.org/drawingml/2006/main" xmlns:p="http://schemas.openxmlformats.org/presentationml/2006/main" xmlns:r="http://schemas.openxmlformats.org/officeDocument/2006/relationships">
   <p:cSld>
     <p:spTree>
       <p:nvGrpSpPr>
@@ -3373,14 +5133,7 @@
         <p:cNvGrpSpPr/>
         <p:nvPr/>
       </p:nvGrpSpPr>
-      <p:grpSpPr>
-        <a:xfrm>
-          <a:off x="0" y="0"/>
-          <a:ext cx="0" cy="0"/>
-          <a:chOff x="0" y="0"/>
-          <a:chExt cx="0" cy="0"/>
-        </a:xfrm>
-      </p:grpSpPr>
+      <p:grpSpPr/>
       <p:sp>
         <p:nvSpPr>
           <p:cNvPr id="2" name="Title 1"/>
@@ -3397,7 +5150,7 @@
           <a:lstStyle/>
           <a:p>
             <a:r>
-              <a:t>The Brains: Model &amp; Dataset</a:t>
+              <a:t>Objectives, and Where They Ended Up</a:t>
             </a:r>
           </a:p>
         </p:txBody>
@@ -3414,39 +5167,116 @@
         </p:nvSpPr>
         <p:spPr/>
         <p:txBody>
-          <a:bodyPr/>
-          <a:lstStyle/>
-          <a:p>
-            <a:r>
-              <a:t>The Dataset: Trained on the MIT Plagiarism Detection Dataset.</a:t>
-            </a:r>
-          </a:p>
-          <a:p>
-            <a:r>
-              <a:t>The AI Model: Used Sentence-BERT (all-MiniLM-L6-v2).</a:t>
-            </a:r>
-          </a:p>
-          <a:p>
-            <a:r>
-              <a:t>Siamese Network Architecture:</a:t>
-            </a:r>
-          </a:p>
-          <a:p>
-            <a:pPr lvl="1"/>
-            <a:r>
-              <a:t>It uses twin AI networks that share the same brain (weights).</a:t>
-            </a:r>
-          </a:p>
-          <a:p>
-            <a:pPr lvl="1"/>
-            <a:r>
-              <a:t>Both sentences go through the twins to create meaning-numbers (embeddings).</a:t>
-            </a:r>
-          </a:p>
-          <a:p>
-            <a:pPr lvl="1"/>
-            <a:r>
-              <a:t>If they mean the same thing, the network pulls them closer together.</a:t>
+          <a:bodyPr wrap="square"/>
+          <a:lstStyle/>
+          <a:p>
+            <a:pPr>
+              <a:spcAft>
+                <a:spcPts val="600"/>
+              </a:spcAft>
+            </a:pPr>
+            <a:r>
+              <a:rPr sz="1800" b="0"/>
+              <a:t>1. Compare a batch of documents against each other</a:t>
+            </a:r>
+          </a:p>
+          <a:p>
+            <a:pPr lvl="1">
+              <a:spcAft>
+                <a:spcPts val="600"/>
+              </a:spcAft>
+            </a:pPr>
+            <a:r>
+              <a:rPr sz="1500" b="0"/>
+              <a:t>Done: n x n matrix, percentage copied and the matched sentences for every flagged pair.</a:t>
+            </a:r>
+          </a:p>
+          <a:p>
+            <a:pPr>
+              <a:spcAft>
+                <a:spcPts val="600"/>
+              </a:spcAft>
+            </a:pPr>
+            <a:r>
+              <a:rPr sz="1800" b="0"/>
+              <a:t>2. Check a document against public web pages</a:t>
+            </a:r>
+          </a:p>
+          <a:p>
+            <a:pPr lvl="1">
+              <a:spcAft>
+                <a:spcPts val="600"/>
+              </a:spcAft>
+            </a:pPr>
+            <a:r>
+              <a:rPr sz="1500" b="0"/>
+              <a:t>Done: keyword search, page fetch, sentence level comparison.</a:t>
+            </a:r>
+          </a:p>
+          <a:p>
+            <a:pPr>
+              <a:spcAft>
+                <a:spcPts val="600"/>
+              </a:spcAft>
+            </a:pPr>
+            <a:r>
+              <a:rPr sz="1800" b="0"/>
+              <a:t>3. Catch paraphrase, and measure it against our own baseline</a:t>
+            </a:r>
+          </a:p>
+          <a:p>
+            <a:pPr lvl="1">
+              <a:spcAft>
+                <a:spcPts val="600"/>
+              </a:spcAft>
+            </a:pPr>
+            <a:r>
+              <a:rPr sz="1500" b="0"/>
+              <a:t>Done: 0.826 accuracy fine tuned against 0.666 for the TF-IDF baseline.</a:t>
+            </a:r>
+          </a:p>
+          <a:p>
+            <a:pPr>
+              <a:spcAft>
+                <a:spcPts val="600"/>
+              </a:spcAft>
+            </a:pPr>
+            <a:r>
+              <a:rPr sz="1800" b="0"/>
+              <a:t>4. Read PDF, DOCX, TXT and scans, in English and Nepali</a:t>
+            </a:r>
+          </a:p>
+          <a:p>
+            <a:pPr lvl="1">
+              <a:spcAft>
+                <a:spcPts val="600"/>
+              </a:spcAft>
+            </a:pPr>
+            <a:r>
+              <a:rPr sz="1500" b="0"/>
+              <a:t>Done: OCR for images and for scanned PDFs; Devanagari handled throughout.</a:t>
+            </a:r>
+          </a:p>
+          <a:p>
+            <a:pPr>
+              <a:spcAft>
+                <a:spcPts val="600"/>
+              </a:spcAft>
+            </a:pPr>
+            <a:r>
+              <a:rPr sz="1800" b="0"/>
+              <a:t>5. Free, no login, nothing kept</a:t>
+            </a:r>
+          </a:p>
+          <a:p>
+            <a:pPr lvl="1">
+              <a:spcAft>
+                <a:spcPts val="600"/>
+              </a:spcAft>
+            </a:pPr>
+            <a:r>
+              <a:rPr sz="1500" b="0"/>
+              <a:t>Done: no uploaded file is written to disk or to a database at any point.</a:t>
             </a:r>
           </a:p>
         </p:txBody>
@@ -3460,7 +5290,7 @@
 </file>
 
 <file path=ppt/slides/slide4.xml><?xml version="1.0" encoding="utf-8"?>
-<p:sld xmlns:a="http://schemas.openxmlformats.org/drawingml/2006/main" xmlns:r="http://schemas.openxmlformats.org/officeDocument/2006/relationships" xmlns:p="http://schemas.openxmlformats.org/presentationml/2006/main">
+<p:sld xmlns:a="http://schemas.openxmlformats.org/drawingml/2006/main" xmlns:p="http://schemas.openxmlformats.org/presentationml/2006/main" xmlns:r="http://schemas.openxmlformats.org/officeDocument/2006/relationships">
   <p:cSld>
     <p:spTree>
       <p:nvGrpSpPr>
@@ -3468,14 +5298,7 @@
         <p:cNvGrpSpPr/>
         <p:nvPr/>
       </p:nvGrpSpPr>
-      <p:grpSpPr>
-        <a:xfrm>
-          <a:off x="0" y="0"/>
-          <a:ext cx="0" cy="0"/>
-          <a:chOff x="0" y="0"/>
-          <a:chExt cx="0" cy="0"/>
-        </a:xfrm>
-      </p:grpSpPr>
+      <p:grpSpPr/>
       <p:sp>
         <p:nvSpPr>
           <p:cNvPr id="2" name="Title 1"/>
@@ -3492,7 +5315,7 @@
           <a:lstStyle/>
           <a:p>
             <a:r>
-              <a:t>Web Scraping &amp; Keyword Extraction</a:t>
+              <a:t>What the Finished System Does</a:t>
             </a:r>
           </a:p>
         </p:txBody>
@@ -3509,46 +5332,72 @@
         </p:nvSpPr>
         <p:spPr/>
         <p:txBody>
-          <a:bodyPr/>
-          <a:lstStyle/>
-          <a:p>
-            <a:r>
-              <a:rPr dirty="0"/>
-              <a:t>Keyword Extraction:</a:t>
-            </a:r>
-          </a:p>
-          <a:p>
-            <a:pPr lvl="1"/>
-            <a:r>
-              <a:rPr dirty="0"/>
-              <a:t>System scans the text and picks the top 6 most frequently used important words (ignoring 'and', 'the').</a:t>
-            </a:r>
-          </a:p>
-          <a:p>
-            <a:r>
-              <a:rPr dirty="0"/>
-              <a:t>Stealthy Scraping:</a:t>
-            </a:r>
-          </a:p>
-          <a:p>
-            <a:pPr lvl="1"/>
-            <a:r>
-              <a:rPr dirty="0"/>
-              <a:t>Searches DuckDuckGo using those keywords to find top 10 URLs.</a:t>
-            </a:r>
-          </a:p>
-          <a:p>
-            <a:pPr lvl="1"/>
-            <a:r>
-              <a:rPr dirty="0"/>
-              <a:t>Visits the URLs and extracts the pure text (ignoring HTML, ads).</a:t>
-            </a:r>
-          </a:p>
-          <a:p>
-            <a:pPr lvl="1"/>
-            <a:r>
-              <a:rPr dirty="0"/>
-              <a:t>Compares the internet text against the uploaded document.</a:t>
+          <a:bodyPr wrap="square"/>
+          <a:lstStyle/>
+          <a:p>
+            <a:pPr>
+              <a:spcAft>
+                <a:spcPts val="600"/>
+              </a:spcAft>
+            </a:pPr>
+            <a:r>
+              <a:rPr sz="1800" b="0"/>
+              <a:t>Upload PDF, Word, text or images. A scanned PDF with no text layer is detected and sent to OCR automatically.</a:t>
+            </a:r>
+          </a:p>
+          <a:p>
+            <a:pPr>
+              <a:spcAft>
+                <a:spcPts val="600"/>
+              </a:spcAft>
+            </a:pPr>
+            <a:r>
+              <a:rPr sz="1800" b="0"/>
+              <a:t>Every document is compared against every other one and the result is drawn as a similarity matrix.</a:t>
+            </a:r>
+          </a:p>
+          <a:p>
+            <a:pPr>
+              <a:spcAft>
+                <a:spcPts val="600"/>
+              </a:spcAft>
+            </a:pPr>
+            <a:r>
+              <a:rPr sz="1800" b="0"/>
+              <a:t>Each flagged pair carries a percentage copied and the sentences that match, marked inside the text.</a:t>
+            </a:r>
+          </a:p>
+          <a:p>
+            <a:pPr>
+              <a:spcAft>
+                <a:spcPts val="600"/>
+              </a:spcAft>
+            </a:pPr>
+            <a:r>
+              <a:rPr sz="1800" b="0"/>
+              <a:t>Any one document can be checked against public web pages.</a:t>
+            </a:r>
+          </a:p>
+          <a:p>
+            <a:pPr>
+              <a:spcAft>
+                <a:spcPts val="600"/>
+              </a:spcAft>
+            </a:pPr>
+            <a:r>
+              <a:rPr sz="1800" b="0"/>
+              <a:t>The engine and the threshold are controls in the interface, not constants in the code.</a:t>
+            </a:r>
+          </a:p>
+          <a:p>
+            <a:pPr>
+              <a:spcAft>
+                <a:spcPts val="600"/>
+              </a:spcAft>
+            </a:pPr>
+            <a:r>
+              <a:rPr sz="1800" b="0"/>
+              <a:t>Nothing is stored. The answer is returned and the file is gone.</a:t>
             </a:r>
           </a:p>
         </p:txBody>
@@ -3562,7 +5411,7 @@
 </file>
 
 <file path=ppt/slides/slide5.xml><?xml version="1.0" encoding="utf-8"?>
-<p:sld xmlns:a="http://schemas.openxmlformats.org/drawingml/2006/main" xmlns:r="http://schemas.openxmlformats.org/officeDocument/2006/relationships" xmlns:p="http://schemas.openxmlformats.org/presentationml/2006/main">
+<p:sld xmlns:a="http://schemas.openxmlformats.org/drawingml/2006/main" xmlns:p="http://schemas.openxmlformats.org/presentationml/2006/main" xmlns:r="http://schemas.openxmlformats.org/officeDocument/2006/relationships">
   <p:cSld>
     <p:spTree>
       <p:nvGrpSpPr>
@@ -3570,14 +5419,7 @@
         <p:cNvGrpSpPr/>
         <p:nvPr/>
       </p:nvGrpSpPr>
-      <p:grpSpPr>
-        <a:xfrm>
-          <a:off x="0" y="0"/>
-          <a:ext cx="0" cy="0"/>
-          <a:chOff x="0" y="0"/>
-          <a:chExt cx="0" cy="0"/>
-        </a:xfrm>
-      </p:grpSpPr>
+      <p:grpSpPr/>
       <p:sp>
         <p:nvSpPr>
           <p:cNvPr id="2" name="Title 1"/>
@@ -3594,43 +5436,65 @@
           <a:lstStyle/>
           <a:p>
             <a:r>
-              <a:t>Remaining Work</a:t>
-            </a:r>
-          </a:p>
-        </p:txBody>
-      </p:sp>
-      <p:sp>
-        <p:nvSpPr>
-          <p:cNvPr id="3" name="Content Placeholder 2"/>
-          <p:cNvSpPr>
-            <a:spLocks noGrp="1"/>
-          </p:cNvSpPr>
-          <p:nvPr>
-            <p:ph idx="1"/>
-          </p:nvPr>
-        </p:nvSpPr>
-        <p:spPr/>
-        <p:txBody>
-          <a:bodyPr/>
-          <a:lstStyle/>
-          <a:p>
-            <a:r>
-              <a:t>Add support for larger documents by splitting them into smaller chunks.</a:t>
-            </a:r>
-          </a:p>
-          <a:p>
-            <a:r>
-              <a:t>Polish the User Interface to make similarity matrix easier to read on small screens.</a:t>
-            </a:r>
-          </a:p>
-          <a:p>
-            <a:r>
-              <a:t>Add support for checking texts in Devanagari (Nepali).</a:t>
-            </a:r>
-          </a:p>
-          <a:p>
-            <a:r>
-              <a:t>Final testing and bug fixing before final submission.</a:t>
+              <a:t>System Architecture</a:t>
+            </a:r>
+          </a:p>
+        </p:txBody>
+      </p:sp>
+      <p:pic>
+        <p:nvPicPr>
+          <p:cNvPr id="3" name="Picture 2" descr="fig1_architecture.png"/>
+          <p:cNvPicPr>
+            <a:picLocks noChangeAspect="1"/>
+          </p:cNvPicPr>
+          <p:nvPr/>
+        </p:nvPicPr>
+        <p:blipFill>
+          <a:blip r:embed="rId2"/>
+          <a:stretch>
+            <a:fillRect/>
+          </a:stretch>
+        </p:blipFill>
+        <p:spPr>
+          <a:xfrm>
+            <a:off x="1695683" y="1371600"/>
+            <a:ext cx="5752633" cy="4389120"/>
+          </a:xfrm>
+          <a:prstGeom prst="rect">
+            <a:avLst/>
+          </a:prstGeom>
+        </p:spPr>
+      </p:pic>
+      <p:sp>
+        <p:nvSpPr>
+          <p:cNvPr id="4" name="TextBox 3"/>
+          <p:cNvSpPr txBox="1"/>
+          <p:nvPr/>
+        </p:nvSpPr>
+        <p:spPr>
+          <a:xfrm>
+            <a:off x="457200" y="5943600"/>
+            <a:ext cx="8229600" cy="640080"/>
+          </a:xfrm>
+          <a:prstGeom prst="rect">
+            <a:avLst/>
+          </a:prstGeom>
+          <a:noFill/>
+        </p:spPr>
+        <p:txBody>
+          <a:bodyPr wrap="none">
+            <a:spAutoFit/>
+          </a:bodyPr>
+          <a:lstStyle/>
+          <a:p>
+            <a:pPr algn="ctr"/>
+            <a:r>
+              <a:rPr sz="1400" i="1">
+                <a:solidFill>
+                  <a:srgbClr val="5A5A5A"/>
+                </a:solidFill>
+              </a:rPr>
+              <a:t>React frontend, Django REST backend, five independent services.</a:t>
             </a:r>
           </a:p>
         </p:txBody>
@@ -3644,7 +5508,7 @@
 </file>
 
 <file path=ppt/slides/slide6.xml><?xml version="1.0" encoding="utf-8"?>
-<p:sld xmlns:a="http://schemas.openxmlformats.org/drawingml/2006/main" xmlns:r="http://schemas.openxmlformats.org/officeDocument/2006/relationships" xmlns:p="http://schemas.openxmlformats.org/presentationml/2006/main">
+<p:sld xmlns:a="http://schemas.openxmlformats.org/drawingml/2006/main" xmlns:p="http://schemas.openxmlformats.org/presentationml/2006/main" xmlns:r="http://schemas.openxmlformats.org/officeDocument/2006/relationships">
   <p:cSld>
     <p:spTree>
       <p:nvGrpSpPr>
@@ -3652,14 +5516,7 @@
         <p:cNvGrpSpPr/>
         <p:nvPr/>
       </p:nvGrpSpPr>
-      <p:grpSpPr>
-        <a:xfrm>
-          <a:off x="0" y="0"/>
-          <a:ext cx="0" cy="0"/>
-          <a:chOff x="0" y="0"/>
-          <a:chExt cx="0" cy="0"/>
-        </a:xfrm>
-      </p:grpSpPr>
+      <p:grpSpPr/>
       <p:sp>
         <p:nvSpPr>
           <p:cNvPr id="2" name="Title 1"/>
@@ -3667,37 +5524,578 @@
             <a:spLocks noGrp="1"/>
           </p:cNvSpPr>
           <p:nvPr>
-            <p:ph type="ctrTitle"/>
-          </p:nvPr>
-        </p:nvSpPr>
-        <p:spPr/>
-        <p:txBody>
-          <a:bodyPr/>
-          <a:lstStyle/>
-          <a:p>
-            <a:r>
-              <a:t>Thank You!</a:t>
-            </a:r>
-          </a:p>
-        </p:txBody>
-      </p:sp>
-      <p:sp>
-        <p:nvSpPr>
-          <p:cNvPr id="3" name="Subtitle 2"/>
-          <p:cNvSpPr>
-            <a:spLocks noGrp="1"/>
-          </p:cNvSpPr>
-          <p:nvPr>
-            <p:ph type="subTitle" idx="1"/>
-          </p:nvPr>
-        </p:nvSpPr>
-        <p:spPr/>
-        <p:txBody>
-          <a:bodyPr/>
-          <a:lstStyle/>
-          <a:p>
-            <a:r>
-              <a:t>Questions &amp; Feedback?</a:t>
+            <p:ph type="title"/>
+          </p:nvPr>
+        </p:nvSpPr>
+        <p:spPr/>
+        <p:txBody>
+          <a:bodyPr/>
+          <a:lstStyle/>
+          <a:p>
+            <a:r>
+              <a:t>How a Comparison Runs</a:t>
+            </a:r>
+          </a:p>
+        </p:txBody>
+      </p:sp>
+      <p:sp>
+        <p:nvSpPr>
+          <p:cNvPr id="3" name="Content Placeholder 2"/>
+          <p:cNvSpPr>
+            <a:spLocks noGrp="1"/>
+          </p:cNvSpPr>
+          <p:nvPr>
+            <p:ph idx="1"/>
+          </p:nvPr>
+        </p:nvSpPr>
+        <p:spPr/>
+        <p:txBody>
+          <a:bodyPr wrap="square"/>
+          <a:lstStyle/>
+          <a:p>
+            <a:pPr>
+              <a:spcAft>
+                <a:spcPts val="600"/>
+              </a:spcAft>
+            </a:pPr>
+            <a:r>
+              <a:rPr sz="1700" b="1">
+                <a:solidFill>
+                  <a:srgbClr val="1F3B73"/>
+                </a:solidFill>
+              </a:rPr>
+              <a:t>1. Read the document</a:t>
+            </a:r>
+          </a:p>
+          <a:p>
+            <a:pPr lvl="1">
+              <a:spcAft>
+                <a:spcPts val="600"/>
+              </a:spcAft>
+            </a:pPr>
+            <a:r>
+              <a:rPr sz="1400" b="0"/>
+              <a:t>TXT and DOCX directly, PDF through a parser, images through Tesseract. No text layer means OCR.</a:t>
+            </a:r>
+          </a:p>
+          <a:p>
+            <a:pPr>
+              <a:spcAft>
+                <a:spcPts val="600"/>
+              </a:spcAft>
+            </a:pPr>
+            <a:r>
+              <a:rPr sz="1700" b="1">
+                <a:solidFill>
+                  <a:srgbClr val="1F3B73"/>
+                </a:solidFill>
+              </a:rPr>
+              <a:t>2. Prepare the text</a:t>
+            </a:r>
+          </a:p>
+          <a:p>
+            <a:pPr lvl="1">
+              <a:spcAft>
+                <a:spcPts val="600"/>
+              </a:spcAft>
+            </a:pPr>
+            <a:r>
+              <a:rPr sz="1400" b="0"/>
+              <a:t>Clean, normalise the spacing, split into sentences at the full stop, the question mark or the danda.</a:t>
+            </a:r>
+          </a:p>
+          <a:p>
+            <a:pPr>
+              <a:spcAft>
+                <a:spcPts val="600"/>
+              </a:spcAft>
+            </a:pPr>
+            <a:r>
+              <a:rPr sz="1700" b="1">
+                <a:solidFill>
+                  <a:srgbClr val="1F3B73"/>
+                </a:solidFill>
+              </a:rPr>
+              <a:t>3. Compare every pair</a:t>
+            </a:r>
+          </a:p>
+          <a:p>
+            <a:pPr lvl="1">
+              <a:spcAft>
+                <a:spcPts val="600"/>
+              </a:spcAft>
+            </a:pPr>
+            <a:r>
+              <a:rPr sz="1400" b="0"/>
+              <a:t>One vector per document, cosine against every other, which produces the matrix.</a:t>
+            </a:r>
+          </a:p>
+          <a:p>
+            <a:pPr>
+              <a:spcAft>
+                <a:spcPts val="600"/>
+              </a:spcAft>
+            </a:pPr>
+            <a:r>
+              <a:rPr sz="1700" b="1">
+                <a:solidFill>
+                  <a:srgbClr val="1F3B73"/>
+                </a:solidFill>
+              </a:rPr>
+              <a:t>4. Check against the web</a:t>
+            </a:r>
+          </a:p>
+          <a:p>
+            <a:pPr lvl="1">
+              <a:spcAft>
+                <a:spcPts val="600"/>
+              </a:spcAft>
+            </a:pPr>
+            <a:r>
+              <a:rPr sz="1400" b="0"/>
+              <a:t>Frequent words become a query, pages are fetched and stripped, then compared.</a:t>
+            </a:r>
+          </a:p>
+          <a:p>
+            <a:pPr>
+              <a:spcAft>
+                <a:spcPts val="600"/>
+              </a:spcAft>
+            </a:pPr>
+            <a:r>
+              <a:rPr sz="1700" b="1">
+                <a:solidFill>
+                  <a:srgbClr val="1F3B73"/>
+                </a:solidFill>
+              </a:rPr>
+              <a:t>5. Show the result</a:t>
+            </a:r>
+          </a:p>
+          <a:p>
+            <a:pPr lvl="1">
+              <a:spcAft>
+                <a:spcPts val="600"/>
+              </a:spcAft>
+            </a:pPr>
+            <a:r>
+              <a:rPr sz="1400" b="0"/>
+              <a:t>Matrix, percentage copied and matched sentences, returned as JSON and drawn by React.</a:t>
+            </a:r>
+          </a:p>
+        </p:txBody>
+      </p:sp>
+    </p:spTree>
+  </p:cSld>
+  <p:clrMapOvr>
+    <a:masterClrMapping/>
+  </p:clrMapOvr>
+</p:sld>
+</file>
+
+<file path=ppt/slides/slide7.xml><?xml version="1.0" encoding="utf-8"?>
+<p:sld xmlns:a="http://schemas.openxmlformats.org/drawingml/2006/main" xmlns:p="http://schemas.openxmlformats.org/presentationml/2006/main" xmlns:r="http://schemas.openxmlformats.org/officeDocument/2006/relationships">
+  <p:cSld>
+    <p:spTree>
+      <p:nvGrpSpPr>
+        <p:cNvPr id="1" name=""/>
+        <p:cNvGrpSpPr/>
+        <p:nvPr/>
+      </p:nvGrpSpPr>
+      <p:grpSpPr/>
+      <p:sp>
+        <p:nvSpPr>
+          <p:cNvPr id="2" name="Title 1"/>
+          <p:cNvSpPr>
+            <a:spLocks noGrp="1"/>
+          </p:cNvSpPr>
+          <p:nvPr>
+            <p:ph type="title"/>
+          </p:nvPr>
+        </p:nvSpPr>
+        <p:spPr/>
+        <p:txBody>
+          <a:bodyPr/>
+          <a:lstStyle/>
+          <a:p>
+            <a:r>
+              <a:t>The Model: Sentence-BERT, Fine Tuned</a:t>
+            </a:r>
+          </a:p>
+        </p:txBody>
+      </p:sp>
+      <p:sp>
+        <p:nvSpPr>
+          <p:cNvPr id="3" name="Content Placeholder 2"/>
+          <p:cNvSpPr>
+            <a:spLocks noGrp="1"/>
+          </p:cNvSpPr>
+          <p:nvPr>
+            <p:ph idx="1"/>
+          </p:nvPr>
+        </p:nvSpPr>
+        <p:spPr/>
+        <p:txBody>
+          <a:bodyPr wrap="square"/>
+          <a:lstStyle/>
+          <a:p>
+            <a:pPr>
+              <a:spcAft>
+                <a:spcPts val="600"/>
+              </a:spcAft>
+            </a:pPr>
+            <a:r>
+              <a:rPr sz="1700" b="0"/>
+              <a:t>Base model: all-MiniLM-L6-v2, a distilled six layer transformer that runs on the laptops we own.</a:t>
+            </a:r>
+          </a:p>
+          <a:p>
+            <a:pPr>
+              <a:spcAft>
+                <a:spcPts val="600"/>
+              </a:spcAft>
+            </a:pPr>
+            <a:r>
+              <a:rPr sz="1700" b="1">
+                <a:solidFill>
+                  <a:srgbClr val="1F3B73"/>
+                </a:solidFill>
+              </a:rPr>
+              <a:t>Siamese architecture:</a:t>
+            </a:r>
+          </a:p>
+          <a:p>
+            <a:pPr lvl="1">
+              <a:spcAft>
+                <a:spcPts val="600"/>
+              </a:spcAft>
+            </a:pPr>
+            <a:r>
+              <a:rPr sz="1400" b="0"/>
+              <a:t>Two copies of one network share their weights.</a:t>
+            </a:r>
+          </a:p>
+          <a:p>
+            <a:pPr lvl="1">
+              <a:spcAft>
+                <a:spcPts val="600"/>
+              </a:spcAft>
+            </a:pPr>
+            <a:r>
+              <a:rPr sz="1400" b="0"/>
+              <a:t>Each side turns a sentence into a fixed vector.</a:t>
+            </a:r>
+          </a:p>
+          <a:p>
+            <a:pPr lvl="1">
+              <a:spcAft>
+                <a:spcPts val="600"/>
+              </a:spcAft>
+            </a:pPr>
+            <a:r>
+              <a:rPr sz="1400" b="0"/>
+              <a:t>Training pulls a matching pair together and pushes a non-matching pair apart.</a:t>
+            </a:r>
+          </a:p>
+          <a:p>
+            <a:pPr lvl="1">
+              <a:spcAft>
+                <a:spcPts val="600"/>
+              </a:spcAft>
+            </a:pPr>
+            <a:r>
+              <a:rPr sz="1400" b="0"/>
+              <a:t>Encode each sentence once, then compare any two with a cosine. A batch costs one encoding pass, not one pass per pair.</a:t>
+            </a:r>
+          </a:p>
+          <a:p>
+            <a:pPr>
+              <a:spcAft>
+                <a:spcPts val="600"/>
+              </a:spcAft>
+            </a:pPr>
+            <a:r>
+              <a:rPr sz="1700" b="1">
+                <a:solidFill>
+                  <a:srgbClr val="1F3B73"/>
+                </a:solidFill>
+              </a:rPr>
+              <a:t>Training data: 30,000 labelled pairs from the Quora Question Pairs corpus.</a:t>
+            </a:r>
+          </a:p>
+          <a:p>
+            <a:pPr lvl="1">
+              <a:spcAft>
+                <a:spcPts val="600"/>
+              </a:spcAft>
+            </a:pPr>
+            <a:r>
+              <a:rPr sz="1400" b="0"/>
+              <a:t>27,000 for training against 3,000 held back. One epoch, batch size 32, cosine similarity loss.</a:t>
+            </a:r>
+          </a:p>
+          <a:p>
+            <a:pPr lvl="1">
+              <a:spcAft>
+                <a:spcPts val="600"/>
+              </a:spcAft>
+            </a:pPr>
+            <a:r>
+              <a:rPr sz="1400" b="0"/>
+              <a:t>Evaluated on a second corpus (MRPC) the model had never seen.</a:t>
+            </a:r>
+          </a:p>
+        </p:txBody>
+      </p:sp>
+    </p:spTree>
+  </p:cSld>
+  <p:clrMapOvr>
+    <a:masterClrMapping/>
+  </p:clrMapOvr>
+</p:sld>
+</file>
+
+<file path=ppt/slides/slide8.xml><?xml version="1.0" encoding="utf-8"?>
+<p:sld xmlns:a="http://schemas.openxmlformats.org/drawingml/2006/main" xmlns:p="http://schemas.openxmlformats.org/presentationml/2006/main" xmlns:r="http://schemas.openxmlformats.org/officeDocument/2006/relationships">
+  <p:cSld>
+    <p:spTree>
+      <p:nvGrpSpPr>
+        <p:cNvPr id="1" name=""/>
+        <p:cNvGrpSpPr/>
+        <p:nvPr/>
+      </p:nvGrpSpPr>
+      <p:grpSpPr/>
+      <p:sp>
+        <p:nvSpPr>
+          <p:cNvPr id="2" name="Title 1"/>
+          <p:cNvSpPr>
+            <a:spLocks noGrp="1"/>
+          </p:cNvSpPr>
+          <p:nvPr>
+            <p:ph type="title"/>
+          </p:nvPr>
+        </p:nvSpPr>
+        <p:spPr/>
+        <p:txBody>
+          <a:bodyPr/>
+          <a:lstStyle/>
+          <a:p>
+            <a:r>
+              <a:t>The Baseline We Wrote Ourselves</a:t>
+            </a:r>
+          </a:p>
+        </p:txBody>
+      </p:sp>
+      <p:sp>
+        <p:nvSpPr>
+          <p:cNvPr id="3" name="Content Placeholder 2"/>
+          <p:cNvSpPr>
+            <a:spLocks noGrp="1"/>
+          </p:cNvSpPr>
+          <p:nvPr>
+            <p:ph idx="1"/>
+          </p:nvPr>
+        </p:nvSpPr>
+        <p:spPr/>
+        <p:txBody>
+          <a:bodyPr wrap="square"/>
+          <a:lstStyle/>
+          <a:p>
+            <a:pPr>
+              <a:spcAft>
+                <a:spcPts val="600"/>
+              </a:spcAft>
+            </a:pPr>
+            <a:r>
+              <a:rPr sz="1800" b="0"/>
+              <a:t>TF-IDF with cosine similarity, built from scratch with PyTorch tensors rather than imported from a library.</a:t>
+            </a:r>
+          </a:p>
+          <a:p>
+            <a:pPr>
+              <a:spcAft>
+                <a:spcPts val="600"/>
+              </a:spcAft>
+            </a:pPr>
+            <a:r>
+              <a:rPr sz="1800" b="0"/>
+              <a:t>Both engines then run on the same tensors and the same cosine, so any difference between them belongs to the model and not to somebody else’s optimised library code.</a:t>
+            </a:r>
+          </a:p>
+          <a:p>
+            <a:pPr>
+              <a:spcAft>
+                <a:spcPts val="600"/>
+              </a:spcAft>
+            </a:pPr>
+            <a:r>
+              <a:rPr sz="1800" b="0"/>
+              <a:t>It stayed inside the shipped system instead of being deleted once the trained model worked, and it is a switch in the interface.</a:t>
+            </a:r>
+          </a:p>
+          <a:p>
+            <a:pPr>
+              <a:spcAft>
+                <a:spcPts val="600"/>
+              </a:spcAft>
+            </a:pPr>
+            <a:r>
+              <a:rPr sz="1800" b="0"/>
+              <a:t>Without it, the claim that our model detects paraphrase would rest on nothing anyone could check.</a:t>
+            </a:r>
+          </a:p>
+        </p:txBody>
+      </p:sp>
+    </p:spTree>
+  </p:cSld>
+  <p:clrMapOvr>
+    <a:masterClrMapping/>
+  </p:clrMapOvr>
+</p:sld>
+</file>
+
+<file path=ppt/slides/slide9.xml><?xml version="1.0" encoding="utf-8"?>
+<p:sld xmlns:a="http://schemas.openxmlformats.org/drawingml/2006/main" xmlns:p="http://schemas.openxmlformats.org/presentationml/2006/main" xmlns:r="http://schemas.openxmlformats.org/officeDocument/2006/relationships">
+  <p:cSld>
+    <p:spTree>
+      <p:nvGrpSpPr>
+        <p:cNvPr id="1" name=""/>
+        <p:cNvGrpSpPr/>
+        <p:nvPr/>
+      </p:nvGrpSpPr>
+      <p:grpSpPr/>
+      <p:sp>
+        <p:nvSpPr>
+          <p:cNvPr id="2" name="Title 1"/>
+          <p:cNvSpPr>
+            <a:spLocks noGrp="1"/>
+          </p:cNvSpPr>
+          <p:nvPr>
+            <p:ph type="title"/>
+          </p:nvPr>
+        </p:nvSpPr>
+        <p:spPr/>
+        <p:txBody>
+          <a:bodyPr/>
+          <a:lstStyle/>
+          <a:p>
+            <a:r>
+              <a:t>Checking Against the Web</a:t>
+            </a:r>
+          </a:p>
+        </p:txBody>
+      </p:sp>
+      <p:sp>
+        <p:nvSpPr>
+          <p:cNvPr id="3" name="Content Placeholder 2"/>
+          <p:cNvSpPr>
+            <a:spLocks noGrp="1"/>
+          </p:cNvSpPr>
+          <p:nvPr>
+            <p:ph idx="1"/>
+          </p:nvPr>
+        </p:nvSpPr>
+        <p:spPr/>
+        <p:txBody>
+          <a:bodyPr wrap="square"/>
+          <a:lstStyle/>
+          <a:p>
+            <a:pPr>
+              <a:spcAft>
+                <a:spcPts val="600"/>
+              </a:spcAft>
+            </a:pPr>
+            <a:r>
+              <a:rPr sz="1800" b="1">
+                <a:solidFill>
+                  <a:srgbClr val="1F3B73"/>
+                </a:solidFill>
+              </a:rPr>
+              <a:t>Keyword extraction</a:t>
+            </a:r>
+          </a:p>
+          <a:p>
+            <a:pPr lvl="1">
+              <a:spcAft>
+                <a:spcPts val="600"/>
+              </a:spcAft>
+            </a:pPr>
+            <a:r>
+              <a:rPr sz="1500" b="0"/>
+              <a:t>The six most frequent content words become the search query, after the stopwords are dropped.</a:t>
+            </a:r>
+          </a:p>
+          <a:p>
+            <a:pPr>
+              <a:spcAft>
+                <a:spcPts val="600"/>
+              </a:spcAft>
+            </a:pPr>
+            <a:r>
+              <a:rPr sz="1800" b="1">
+                <a:solidFill>
+                  <a:srgbClr val="1F3B73"/>
+                </a:solidFill>
+              </a:rPr>
+              <a:t>Search and fetch</a:t>
+            </a:r>
+          </a:p>
+          <a:p>
+            <a:pPr lvl="1">
+              <a:spcAft>
+                <a:spcPts val="600"/>
+              </a:spcAft>
+            </a:pPr>
+            <a:r>
+              <a:rPr sz="1500" b="0"/>
+              <a:t>The DuckDuckGo HTML endpoint, no API key and no account, returns up to ten URLs.</a:t>
+            </a:r>
+          </a:p>
+          <a:p>
+            <a:pPr lvl="1">
+              <a:spcAft>
+                <a:spcPts val="600"/>
+              </a:spcAft>
+            </a:pPr>
+            <a:r>
+              <a:rPr sz="1500" b="0"/>
+              <a:t>Each page is fetched and the script, style, navigation, header and footer are removed, leaving the paragraph text.</a:t>
+            </a:r>
+          </a:p>
+          <a:p>
+            <a:pPr>
+              <a:spcAft>
+                <a:spcPts val="600"/>
+              </a:spcAft>
+            </a:pPr>
+            <a:r>
+              <a:rPr sz="1800" b="1">
+                <a:solidFill>
+                  <a:srgbClr val="1F3B73"/>
+                </a:solidFill>
+              </a:rPr>
+              <a:t>Compare</a:t>
+            </a:r>
+          </a:p>
+          <a:p>
+            <a:pPr lvl="1">
+              <a:spcAft>
+                <a:spcPts val="600"/>
+              </a:spcAft>
+            </a:pPr>
+            <a:r>
+              <a:rPr sz="1500" b="0"/>
+              <a:t>The page is scored against the document and its matching sentences are listed.</a:t>
+            </a:r>
+          </a:p>
+          <a:p>
+            <a:pPr lvl="1">
+              <a:spcAft>
+                <a:spcPts val="600"/>
+              </a:spcAft>
+            </a:pPr>
+            <a:r>
+              <a:rPr sz="1500" b="0"/>
+              <a:t>A page that is blocked or slow is skipped, so one dead link never breaks the check.</a:t>
             </a:r>
           </a:p>
         </p:txBody>

</xml_diff>